<commit_message>
Remove developer name from presentation
</commit_message>
<xml_diff>
--- a/app/static/My-ThreatLens-Presentation.pptx
+++ b/app/static/My-ThreatLens-Presentation.pptx
@@ -2,27 +2,27 @@
 <file path=ppt/presentation.xml><?xml version="1.0" encoding="utf-8"?>
 <p:presentation xmlns:p="http://schemas.openxmlformats.org/presentationml/2006/main">
   <p:sldMasterIdLst>
-    <p:sldMasterId xmlns:r="http://schemas.openxmlformats.org/officeDocument/2006/relationships" id="2147483648" r:id="Re786f7c0e6cf4d79"/>
+    <p:sldMasterId xmlns:r="http://schemas.openxmlformats.org/officeDocument/2006/relationships" id="2147483648" r:id="R62e15ba9d86c441b"/>
   </p:sldMasterIdLst>
   <p:notesMasterIdLst>
-    <p:notesMasterId xmlns:r="http://schemas.openxmlformats.org/officeDocument/2006/relationships" r:id="R260ad2a4f3fa4591"/>
+    <p:notesMasterId xmlns:r="http://schemas.openxmlformats.org/officeDocument/2006/relationships" r:id="R02d3458f75ca4006"/>
   </p:notesMasterIdLst>
   <p:sldIdLst>
-    <p:sldId xmlns:r="http://schemas.openxmlformats.org/officeDocument/2006/relationships" id="256" r:id="Re8874e724dec4d50"/>
-    <p:sldId xmlns:r="http://schemas.openxmlformats.org/officeDocument/2006/relationships" id="257" r:id="R0ea6164df33343de"/>
-    <p:sldId xmlns:r="http://schemas.openxmlformats.org/officeDocument/2006/relationships" id="258" r:id="R8c2827324ae34fcb"/>
-    <p:sldId xmlns:r="http://schemas.openxmlformats.org/officeDocument/2006/relationships" id="259" r:id="R09360b3dc8d948ea"/>
-    <p:sldId xmlns:r="http://schemas.openxmlformats.org/officeDocument/2006/relationships" id="260" r:id="Ree8094f3e0184e49"/>
-    <p:sldId xmlns:r="http://schemas.openxmlformats.org/officeDocument/2006/relationships" id="261" r:id="R885f388c1c38431c"/>
-    <p:sldId xmlns:r="http://schemas.openxmlformats.org/officeDocument/2006/relationships" id="262" r:id="Rf6b67be4c3054f5e"/>
-    <p:sldId xmlns:r="http://schemas.openxmlformats.org/officeDocument/2006/relationships" id="263" r:id="R1ab518e30e894893"/>
-    <p:sldId xmlns:r="http://schemas.openxmlformats.org/officeDocument/2006/relationships" id="264" r:id="Rf6ff2a49fd9b4952"/>
-    <p:sldId xmlns:r="http://schemas.openxmlformats.org/officeDocument/2006/relationships" id="265" r:id="Raa7b4f13a3d144fe"/>
-    <p:sldId xmlns:r="http://schemas.openxmlformats.org/officeDocument/2006/relationships" id="266" r:id="R36f98403e84243b0"/>
-    <p:sldId xmlns:r="http://schemas.openxmlformats.org/officeDocument/2006/relationships" id="267" r:id="Rd9aa7c67ad7a4f72"/>
-    <p:sldId xmlns:r="http://schemas.openxmlformats.org/officeDocument/2006/relationships" id="268" r:id="R7b41be73229340c3"/>
-    <p:sldId xmlns:r="http://schemas.openxmlformats.org/officeDocument/2006/relationships" id="269" r:id="Rb90a25ea5ef5487f"/>
-    <p:sldId xmlns:r="http://schemas.openxmlformats.org/officeDocument/2006/relationships" id="270" r:id="R63b9a4579d754b2d"/>
+    <p:sldId xmlns:r="http://schemas.openxmlformats.org/officeDocument/2006/relationships" id="256" r:id="R1a9648cd4e4a4860"/>
+    <p:sldId xmlns:r="http://schemas.openxmlformats.org/officeDocument/2006/relationships" id="257" r:id="R7fb2961f68a24d4b"/>
+    <p:sldId xmlns:r="http://schemas.openxmlformats.org/officeDocument/2006/relationships" id="258" r:id="R404f5e57ae214671"/>
+    <p:sldId xmlns:r="http://schemas.openxmlformats.org/officeDocument/2006/relationships" id="259" r:id="R97a2bacfebac48cb"/>
+    <p:sldId xmlns:r="http://schemas.openxmlformats.org/officeDocument/2006/relationships" id="260" r:id="R0c2d1eb628f94a28"/>
+    <p:sldId xmlns:r="http://schemas.openxmlformats.org/officeDocument/2006/relationships" id="261" r:id="Ra755f51752704c96"/>
+    <p:sldId xmlns:r="http://schemas.openxmlformats.org/officeDocument/2006/relationships" id="262" r:id="R46cf4a636f6c439c"/>
+    <p:sldId xmlns:r="http://schemas.openxmlformats.org/officeDocument/2006/relationships" id="263" r:id="R00687f2b1880427b"/>
+    <p:sldId xmlns:r="http://schemas.openxmlformats.org/officeDocument/2006/relationships" id="264" r:id="R1dc7f977b58b4cc4"/>
+    <p:sldId xmlns:r="http://schemas.openxmlformats.org/officeDocument/2006/relationships" id="265" r:id="Rc85bbfc10b744fcf"/>
+    <p:sldId xmlns:r="http://schemas.openxmlformats.org/officeDocument/2006/relationships" id="266" r:id="R15e4c9b4a6554153"/>
+    <p:sldId xmlns:r="http://schemas.openxmlformats.org/officeDocument/2006/relationships" id="267" r:id="R3b4b41a0da694248"/>
+    <p:sldId xmlns:r="http://schemas.openxmlformats.org/officeDocument/2006/relationships" id="268" r:id="R147baf797d17420d"/>
+    <p:sldId xmlns:r="http://schemas.openxmlformats.org/officeDocument/2006/relationships" id="269" r:id="R30f42c9494964e29"/>
+    <p:sldId xmlns:r="http://schemas.openxmlformats.org/officeDocument/2006/relationships" id="270" r:id="R89e0c5a8310f420d"/>
   </p:sldIdLst>
   <p:sldSz cx="12192000" cy="6858000"/>
   <p:notesSz cx="6858000" cy="9144000"/>
@@ -1804,7 +1804,7 @@
   </p:cSld>
   <p:clrMap bg1="lt1" tx1="dk1" bg2="lt2" tx2="dk2" accent1="accent1" accent2="accent2" accent3="accent3" accent4="accent4" accent5="accent5" accent6="accent6" hlink="hlink" folHlink="folHlink"/>
   <p:sldLayoutIdLst>
-    <p:sldLayoutId xmlns:r="http://schemas.openxmlformats.org/officeDocument/2006/relationships" id="2147483649" r:id="R96e4c1f349384a7a"/>
+    <p:sldLayoutId xmlns:r="http://schemas.openxmlformats.org/officeDocument/2006/relationships" id="2147483649" r:id="R9d1a98b6645f4d97"/>
   </p:sldLayoutIdLst>
   <p:txStyles>
     <p:titleStyle>
@@ -2385,6 +2385,7 @@
           <a:lstStyle xmlns:a="http://schemas.openxmlformats.org/drawingml/2006/main"/>
           <a:p xmlns:a="http://schemas.openxmlformats.org/drawingml/2006/main">
             <a:pPr algn="l">
+              <a:buNone/>
               <a:defRPr sz="1050" b="1">
                 <a:solidFill>
                   <a:srgbClr val="0F766E"/>
@@ -2443,6 +2444,7 @@
           <a:lstStyle xmlns:a="http://schemas.openxmlformats.org/drawingml/2006/main"/>
           <a:p xmlns:a="http://schemas.openxmlformats.org/drawingml/2006/main">
             <a:pPr algn="l">
+              <a:buNone/>
               <a:defRPr sz="4350" b="1">
                 <a:solidFill>
                   <a:srgbClr val="063E62"/>
@@ -2501,6 +2503,7 @@
           <a:lstStyle xmlns:a="http://schemas.openxmlformats.org/drawingml/2006/main"/>
           <a:p xmlns:a="http://schemas.openxmlformats.org/drawingml/2006/main">
             <a:pPr algn="l">
+              <a:buNone/>
               <a:defRPr sz="2250" b="1">
                 <a:solidFill>
                   <a:srgbClr val="17364A"/>
@@ -2524,6 +2527,7 @@
           </a:p>
           <a:p xmlns:a="http://schemas.openxmlformats.org/drawingml/2006/main">
             <a:pPr algn="l">
+              <a:buNone/>
               <a:defRPr sz="2250" b="1">
                 <a:solidFill>
                   <a:srgbClr val="17364A"/>
@@ -2582,6 +2586,7 @@
           <a:lstStyle xmlns:a="http://schemas.openxmlformats.org/drawingml/2006/main"/>
           <a:p xmlns:a="http://schemas.openxmlformats.org/drawingml/2006/main">
             <a:pPr algn="l">
+              <a:buNone/>
               <a:defRPr sz="1425" b="0">
                 <a:solidFill>
                   <a:srgbClr val="5E7483"/>
@@ -2607,14 +2612,14 @@
       </p:sp>
       <p:pic>
         <p:nvPicPr>
-          <p:cNvPr id="12" name=""/>
+          <p:cNvPr id="14" name=""/>
           <p:cNvPicPr>
             <a:picLocks xmlns:a="http://schemas.openxmlformats.org/drawingml/2006/main" noChangeAspect="1"/>
           </p:cNvPicPr>
           <p:nvPr/>
         </p:nvPicPr>
         <p:blipFill>
-          <a:blip xmlns:r="http://schemas.openxmlformats.org/officeDocument/2006/relationships" xmlns:a="http://schemas.openxmlformats.org/drawingml/2006/main" r:embed="R075ae89260724904"/>
+          <a:blip xmlns:r="http://schemas.openxmlformats.org/officeDocument/2006/relationships" xmlns:a="http://schemas.openxmlformats.org/drawingml/2006/main" r:embed="Redd424a616cf431a"/>
           <a:srcRect xmlns:a="http://schemas.openxmlformats.org/drawingml/2006/main" l="22561" t="0" r="22561" b="0"/>
           <a:stretch xmlns:a="http://schemas.openxmlformats.org/drawingml/2006/main">
             <a:fillRect l="0" t="0" r="0" b="0"/>
@@ -2667,6 +2672,7 @@
           <a:lstStyle xmlns:a="http://schemas.openxmlformats.org/drawingml/2006/main"/>
           <a:p xmlns:a="http://schemas.openxmlformats.org/drawingml/2006/main">
             <a:pPr algn="l">
+              <a:buNone/>
               <a:defRPr sz="1050" b="1">
                 <a:solidFill>
                   <a:srgbClr val="5E7483"/>
@@ -2685,7 +2691,7 @@
                 <a:ea typeface="Aptos"/>
                 <a:cs typeface="Aptos"/>
               </a:rPr>
-              <a:t>Developed by Arsen Eliane · Internship project</a:t>
+              <a:t>Internship project</a:t>
             </a:r>
           </a:p>
         </p:txBody>
@@ -2725,6 +2731,7 @@
           <a:lstStyle xmlns:a="http://schemas.openxmlformats.org/drawingml/2006/main"/>
           <a:p xmlns:a="http://schemas.openxmlformats.org/drawingml/2006/main">
             <a:pPr algn="r">
+              <a:buNone/>
               <a:defRPr sz="825" b="1">
                 <a:solidFill>
                   <a:srgbClr val="5E7483"/>
@@ -2805,6 +2812,7 @@
           <a:lstStyle xmlns:a="http://schemas.openxmlformats.org/drawingml/2006/main"/>
           <a:p xmlns:a="http://schemas.openxmlformats.org/drawingml/2006/main">
             <a:pPr algn="l">
+              <a:buNone/>
               <a:defRPr sz="975" b="1">
                 <a:solidFill>
                   <a:srgbClr val="0F766E"/>
@@ -2863,6 +2871,7 @@
           <a:lstStyle xmlns:a="http://schemas.openxmlformats.org/drawingml/2006/main"/>
           <a:p xmlns:a="http://schemas.openxmlformats.org/drawingml/2006/main">
             <a:pPr algn="l">
+              <a:buNone/>
               <a:defRPr sz="2850" b="1">
                 <a:solidFill>
                   <a:srgbClr val="063E62"/>
@@ -2921,6 +2930,7 @@
           <a:lstStyle xmlns:a="http://schemas.openxmlformats.org/drawingml/2006/main"/>
           <a:p xmlns:a="http://schemas.openxmlformats.org/drawingml/2006/main">
             <a:pPr algn="r">
+              <a:buNone/>
               <a:defRPr sz="975" b="1">
                 <a:solidFill>
                   <a:srgbClr val="5E7483"/>
@@ -3014,6 +3024,7 @@
           <a:lstStyle xmlns:a="http://schemas.openxmlformats.org/drawingml/2006/main"/>
           <a:p xmlns:a="http://schemas.openxmlformats.org/drawingml/2006/main">
             <a:pPr algn="l">
+              <a:buNone/>
               <a:defRPr sz="900" b="1">
                 <a:solidFill>
                   <a:srgbClr val="0F766E"/>
@@ -3072,6 +3083,7 @@
           <a:lstStyle xmlns:a="http://schemas.openxmlformats.org/drawingml/2006/main"/>
           <a:p xmlns:a="http://schemas.openxmlformats.org/drawingml/2006/main">
             <a:pPr algn="l">
+              <a:buNone/>
               <a:defRPr sz="1500" b="1">
                 <a:solidFill>
                   <a:srgbClr val="063E62"/>
@@ -3130,6 +3142,7 @@
           <a:lstStyle xmlns:a="http://schemas.openxmlformats.org/drawingml/2006/main"/>
           <a:p xmlns:a="http://schemas.openxmlformats.org/drawingml/2006/main">
             <a:pPr algn="l">
+              <a:buNone/>
               <a:defRPr sz="1200" b="0">
                 <a:solidFill>
                   <a:srgbClr val="5E7483"/>
@@ -3223,6 +3236,7 @@
           <a:lstStyle xmlns:a="http://schemas.openxmlformats.org/drawingml/2006/main"/>
           <a:p xmlns:a="http://schemas.openxmlformats.org/drawingml/2006/main">
             <a:pPr algn="l">
+              <a:buNone/>
               <a:defRPr sz="900" b="1">
                 <a:solidFill>
                   <a:srgbClr val="0F766E"/>
@@ -3281,6 +3295,7 @@
           <a:lstStyle xmlns:a="http://schemas.openxmlformats.org/drawingml/2006/main"/>
           <a:p xmlns:a="http://schemas.openxmlformats.org/drawingml/2006/main">
             <a:pPr algn="l">
+              <a:buNone/>
               <a:defRPr sz="1500" b="1">
                 <a:solidFill>
                   <a:srgbClr val="063E62"/>
@@ -3339,6 +3354,7 @@
           <a:lstStyle xmlns:a="http://schemas.openxmlformats.org/drawingml/2006/main"/>
           <a:p xmlns:a="http://schemas.openxmlformats.org/drawingml/2006/main">
             <a:pPr algn="l">
+              <a:buNone/>
               <a:defRPr sz="1200" b="0">
                 <a:solidFill>
                   <a:srgbClr val="5E7483"/>
@@ -3432,6 +3448,7 @@
           <a:lstStyle xmlns:a="http://schemas.openxmlformats.org/drawingml/2006/main"/>
           <a:p xmlns:a="http://schemas.openxmlformats.org/drawingml/2006/main">
             <a:pPr algn="l">
+              <a:buNone/>
               <a:defRPr sz="900" b="1">
                 <a:solidFill>
                   <a:srgbClr val="0F766E"/>
@@ -3490,6 +3507,7 @@
           <a:lstStyle xmlns:a="http://schemas.openxmlformats.org/drawingml/2006/main"/>
           <a:p xmlns:a="http://schemas.openxmlformats.org/drawingml/2006/main">
             <a:pPr algn="l">
+              <a:buNone/>
               <a:defRPr sz="1500" b="1">
                 <a:solidFill>
                   <a:srgbClr val="063E62"/>
@@ -3548,6 +3566,7 @@
           <a:lstStyle xmlns:a="http://schemas.openxmlformats.org/drawingml/2006/main"/>
           <a:p xmlns:a="http://schemas.openxmlformats.org/drawingml/2006/main">
             <a:pPr algn="l">
+              <a:buNone/>
               <a:defRPr sz="1200" b="0">
                 <a:solidFill>
                   <a:srgbClr val="5E7483"/>
@@ -3641,6 +3660,7 @@
           <a:lstStyle xmlns:a="http://schemas.openxmlformats.org/drawingml/2006/main"/>
           <a:p xmlns:a="http://schemas.openxmlformats.org/drawingml/2006/main">
             <a:pPr algn="l">
+              <a:buNone/>
               <a:defRPr sz="900" b="1">
                 <a:solidFill>
                   <a:srgbClr val="0F766E"/>
@@ -3699,6 +3719,7 @@
           <a:lstStyle xmlns:a="http://schemas.openxmlformats.org/drawingml/2006/main"/>
           <a:p xmlns:a="http://schemas.openxmlformats.org/drawingml/2006/main">
             <a:pPr algn="l">
+              <a:buNone/>
               <a:defRPr sz="1500" b="1">
                 <a:solidFill>
                   <a:srgbClr val="063E62"/>
@@ -3757,6 +3778,7 @@
           <a:lstStyle xmlns:a="http://schemas.openxmlformats.org/drawingml/2006/main"/>
           <a:p xmlns:a="http://schemas.openxmlformats.org/drawingml/2006/main">
             <a:pPr algn="l">
+              <a:buNone/>
               <a:defRPr sz="1200" b="0">
                 <a:solidFill>
                   <a:srgbClr val="5E7483"/>
@@ -3850,6 +3872,7 @@
           <a:lstStyle xmlns:a="http://schemas.openxmlformats.org/drawingml/2006/main"/>
           <a:p xmlns:a="http://schemas.openxmlformats.org/drawingml/2006/main">
             <a:pPr algn="l">
+              <a:buNone/>
               <a:defRPr sz="1875" b="1">
                 <a:solidFill>
                   <a:srgbClr val="FFFFFF"/>
@@ -3908,6 +3931,7 @@
           <a:lstStyle xmlns:a="http://schemas.openxmlformats.org/drawingml/2006/main"/>
           <a:p xmlns:a="http://schemas.openxmlformats.org/drawingml/2006/main">
             <a:pPr algn="l">
+              <a:buNone/>
               <a:defRPr sz="1275" b="0">
                 <a:solidFill>
                   <a:srgbClr val="D8EEF4"/>
@@ -3931,6 +3955,7 @@
           </a:p>
           <a:p xmlns:a="http://schemas.openxmlformats.org/drawingml/2006/main">
             <a:pPr algn="l">
+              <a:buNone/>
               <a:defRPr sz="1275" b="0">
                 <a:solidFill>
                   <a:srgbClr val="D8EEF4"/>
@@ -3959,6 +3984,7 @@
           </a:p>
           <a:p xmlns:a="http://schemas.openxmlformats.org/drawingml/2006/main">
             <a:pPr algn="l">
+              <a:buNone/>
               <a:defRPr sz="1275" b="0">
                 <a:solidFill>
                   <a:srgbClr val="D8EEF4"/>
@@ -3982,6 +4008,7 @@
           </a:p>
           <a:p xmlns:a="http://schemas.openxmlformats.org/drawingml/2006/main">
             <a:pPr algn="l">
+              <a:buNone/>
               <a:defRPr sz="1275" b="0">
                 <a:solidFill>
                   <a:srgbClr val="D8EEF4"/>
@@ -4010,6 +4037,7 @@
           </a:p>
           <a:p xmlns:a="http://schemas.openxmlformats.org/drawingml/2006/main">
             <a:pPr algn="l">
+              <a:buNone/>
               <a:defRPr sz="1275" b="0">
                 <a:solidFill>
                   <a:srgbClr val="D8EEF4"/>
@@ -4033,6 +4061,7 @@
           </a:p>
           <a:p xmlns:a="http://schemas.openxmlformats.org/drawingml/2006/main">
             <a:pPr algn="l">
+              <a:buNone/>
               <a:defRPr sz="1275" b="0">
                 <a:solidFill>
                   <a:srgbClr val="D8EEF4"/>
@@ -4061,6 +4090,7 @@
           </a:p>
           <a:p xmlns:a="http://schemas.openxmlformats.org/drawingml/2006/main">
             <a:pPr algn="l">
+              <a:buNone/>
               <a:defRPr sz="1275" b="0">
                 <a:solidFill>
                   <a:srgbClr val="D8EEF4"/>
@@ -4084,6 +4114,7 @@
           </a:p>
           <a:p xmlns:a="http://schemas.openxmlformats.org/drawingml/2006/main">
             <a:pPr algn="l">
+              <a:buNone/>
               <a:defRPr sz="1275" b="0">
                 <a:solidFill>
                   <a:srgbClr val="D8EEF4"/>
@@ -4142,6 +4173,7 @@
           <a:lstStyle xmlns:a="http://schemas.openxmlformats.org/drawingml/2006/main"/>
           <a:p xmlns:a="http://schemas.openxmlformats.org/drawingml/2006/main">
             <a:pPr algn="l">
+              <a:buNone/>
               <a:defRPr sz="750" b="1">
                 <a:solidFill>
                   <a:srgbClr val="5E7483"/>
@@ -4222,6 +4254,7 @@
           <a:lstStyle xmlns:a="http://schemas.openxmlformats.org/drawingml/2006/main"/>
           <a:p xmlns:a="http://schemas.openxmlformats.org/drawingml/2006/main">
             <a:pPr algn="l">
+              <a:buNone/>
               <a:defRPr sz="975" b="1">
                 <a:solidFill>
                   <a:srgbClr val="0F766E"/>
@@ -4280,6 +4313,7 @@
           <a:lstStyle xmlns:a="http://schemas.openxmlformats.org/drawingml/2006/main"/>
           <a:p xmlns:a="http://schemas.openxmlformats.org/drawingml/2006/main">
             <a:pPr algn="l">
+              <a:buNone/>
               <a:defRPr sz="2850" b="1">
                 <a:solidFill>
                   <a:srgbClr val="063E62"/>
@@ -4338,6 +4372,7 @@
           <a:lstStyle xmlns:a="http://schemas.openxmlformats.org/drawingml/2006/main"/>
           <a:p xmlns:a="http://schemas.openxmlformats.org/drawingml/2006/main">
             <a:pPr algn="r">
+              <a:buNone/>
               <a:defRPr sz="975" b="1">
                 <a:solidFill>
                   <a:srgbClr val="5E7483"/>
@@ -4431,6 +4466,7 @@
           <a:lstStyle xmlns:a="http://schemas.openxmlformats.org/drawingml/2006/main"/>
           <a:p xmlns:a="http://schemas.openxmlformats.org/drawingml/2006/main">
             <a:pPr algn="l">
+              <a:buNone/>
               <a:defRPr sz="1875" b="1">
                 <a:solidFill>
                   <a:srgbClr val="063E62"/>
@@ -4489,6 +4525,7 @@
           <a:lstStyle xmlns:a="http://schemas.openxmlformats.org/drawingml/2006/main"/>
           <a:p xmlns:a="http://schemas.openxmlformats.org/drawingml/2006/main">
             <a:pPr algn="l">
+              <a:buNone/>
               <a:defRPr sz="1500" b="0">
                 <a:solidFill>
                   <a:srgbClr val="17364A"/>
@@ -4512,6 +4549,7 @@
           </a:p>
           <a:p xmlns:a="http://schemas.openxmlformats.org/drawingml/2006/main">
             <a:pPr algn="l">
+              <a:buNone/>
               <a:defRPr sz="1500" b="0">
                 <a:solidFill>
                   <a:srgbClr val="17364A"/>
@@ -4535,6 +4573,7 @@
           </a:p>
           <a:p xmlns:a="http://schemas.openxmlformats.org/drawingml/2006/main">
             <a:pPr algn="l">
+              <a:buNone/>
               <a:defRPr sz="1500" b="0">
                 <a:solidFill>
                   <a:srgbClr val="17364A"/>
@@ -4558,6 +4597,7 @@
           </a:p>
           <a:p xmlns:a="http://schemas.openxmlformats.org/drawingml/2006/main">
             <a:pPr algn="l">
+              <a:buNone/>
               <a:defRPr sz="1500" b="0">
                 <a:solidFill>
                   <a:srgbClr val="17364A"/>
@@ -4616,6 +4656,7 @@
           <a:lstStyle xmlns:a="http://schemas.openxmlformats.org/drawingml/2006/main"/>
           <a:p xmlns:a="http://schemas.openxmlformats.org/drawingml/2006/main">
             <a:pPr algn="l">
+              <a:buNone/>
               <a:defRPr sz="1050" b="1">
                 <a:solidFill>
                   <a:srgbClr val="0F766E"/>
@@ -4709,6 +4750,7 @@
           <a:lstStyle xmlns:a="http://schemas.openxmlformats.org/drawingml/2006/main"/>
           <a:p xmlns:a="http://schemas.openxmlformats.org/drawingml/2006/main">
             <a:pPr algn="l">
+              <a:buNone/>
               <a:defRPr sz="1875" b="1">
                 <a:solidFill>
                   <a:srgbClr val="063E62"/>
@@ -4767,6 +4809,7 @@
           <a:lstStyle xmlns:a="http://schemas.openxmlformats.org/drawingml/2006/main"/>
           <a:p xmlns:a="http://schemas.openxmlformats.org/drawingml/2006/main">
             <a:pPr algn="l">
+              <a:buNone/>
               <a:defRPr sz="1500" b="0">
                 <a:solidFill>
                   <a:srgbClr val="17364A"/>
@@ -4790,6 +4833,7 @@
           </a:p>
           <a:p xmlns:a="http://schemas.openxmlformats.org/drawingml/2006/main">
             <a:pPr algn="l">
+              <a:buNone/>
               <a:defRPr sz="1500" b="0">
                 <a:solidFill>
                   <a:srgbClr val="17364A"/>
@@ -4813,6 +4857,7 @@
           </a:p>
           <a:p xmlns:a="http://schemas.openxmlformats.org/drawingml/2006/main">
             <a:pPr algn="l">
+              <a:buNone/>
               <a:defRPr sz="1500" b="0">
                 <a:solidFill>
                   <a:srgbClr val="17364A"/>
@@ -4836,6 +4881,7 @@
           </a:p>
           <a:p xmlns:a="http://schemas.openxmlformats.org/drawingml/2006/main">
             <a:pPr algn="l">
+              <a:buNone/>
               <a:defRPr sz="1500" b="0">
                 <a:solidFill>
                   <a:srgbClr val="17364A"/>
@@ -4894,6 +4940,7 @@
           <a:lstStyle xmlns:a="http://schemas.openxmlformats.org/drawingml/2006/main"/>
           <a:p xmlns:a="http://schemas.openxmlformats.org/drawingml/2006/main">
             <a:pPr algn="l">
+              <a:buNone/>
               <a:defRPr sz="1050" b="1">
                 <a:solidFill>
                   <a:srgbClr val="0F766E"/>
@@ -4952,6 +4999,7 @@
           <a:lstStyle xmlns:a="http://schemas.openxmlformats.org/drawingml/2006/main"/>
           <a:p xmlns:a="http://schemas.openxmlformats.org/drawingml/2006/main">
             <a:pPr algn="ctr">
+              <a:buNone/>
               <a:defRPr sz="1350" b="1">
                 <a:solidFill>
                   <a:srgbClr val="B42318"/>
@@ -5010,6 +5058,7 @@
           <a:lstStyle xmlns:a="http://schemas.openxmlformats.org/drawingml/2006/main"/>
           <a:p xmlns:a="http://schemas.openxmlformats.org/drawingml/2006/main">
             <a:pPr algn="l">
+              <a:buNone/>
               <a:defRPr sz="750" b="1">
                 <a:solidFill>
                   <a:srgbClr val="5E7483"/>
@@ -5090,6 +5139,7 @@
           <a:lstStyle xmlns:a="http://schemas.openxmlformats.org/drawingml/2006/main"/>
           <a:p xmlns:a="http://schemas.openxmlformats.org/drawingml/2006/main">
             <a:pPr algn="l">
+              <a:buNone/>
               <a:defRPr sz="975" b="1">
                 <a:solidFill>
                   <a:srgbClr val="0F766E"/>
@@ -5148,6 +5198,7 @@
           <a:lstStyle xmlns:a="http://schemas.openxmlformats.org/drawingml/2006/main"/>
           <a:p xmlns:a="http://schemas.openxmlformats.org/drawingml/2006/main">
             <a:pPr algn="l">
+              <a:buNone/>
               <a:defRPr sz="2850" b="1">
                 <a:solidFill>
                   <a:srgbClr val="063E62"/>
@@ -5206,6 +5257,7 @@
           <a:lstStyle xmlns:a="http://schemas.openxmlformats.org/drawingml/2006/main"/>
           <a:p xmlns:a="http://schemas.openxmlformats.org/drawingml/2006/main">
             <a:pPr algn="r">
+              <a:buNone/>
               <a:defRPr sz="975" b="1">
                 <a:solidFill>
                   <a:srgbClr val="5E7483"/>
@@ -5299,6 +5351,7 @@
           <a:lstStyle xmlns:a="http://schemas.openxmlformats.org/drawingml/2006/main"/>
           <a:p xmlns:a="http://schemas.openxmlformats.org/drawingml/2006/main">
             <a:pPr algn="l">
+              <a:buNone/>
               <a:defRPr sz="900" b="1">
                 <a:solidFill>
                   <a:srgbClr val="0F766E"/>
@@ -5357,6 +5410,7 @@
           <a:lstStyle xmlns:a="http://schemas.openxmlformats.org/drawingml/2006/main"/>
           <a:p xmlns:a="http://schemas.openxmlformats.org/drawingml/2006/main">
             <a:pPr algn="l">
+              <a:buNone/>
               <a:defRPr sz="1650" b="1">
                 <a:solidFill>
                   <a:srgbClr val="063E62"/>
@@ -5415,6 +5469,7 @@
           <a:lstStyle xmlns:a="http://schemas.openxmlformats.org/drawingml/2006/main"/>
           <a:p xmlns:a="http://schemas.openxmlformats.org/drawingml/2006/main">
             <a:pPr algn="l">
+              <a:buNone/>
               <a:defRPr sz="1275" b="0">
                 <a:solidFill>
                   <a:srgbClr val="5E7483"/>
@@ -5508,6 +5563,7 @@
           <a:lstStyle xmlns:a="http://schemas.openxmlformats.org/drawingml/2006/main"/>
           <a:p xmlns:a="http://schemas.openxmlformats.org/drawingml/2006/main">
             <a:pPr algn="l">
+              <a:buNone/>
               <a:defRPr sz="900" b="1">
                 <a:solidFill>
                   <a:srgbClr val="0F766E"/>
@@ -5566,6 +5622,7 @@
           <a:lstStyle xmlns:a="http://schemas.openxmlformats.org/drawingml/2006/main"/>
           <a:p xmlns:a="http://schemas.openxmlformats.org/drawingml/2006/main">
             <a:pPr algn="l">
+              <a:buNone/>
               <a:defRPr sz="1650" b="1">
                 <a:solidFill>
                   <a:srgbClr val="063E62"/>
@@ -5624,6 +5681,7 @@
           <a:lstStyle xmlns:a="http://schemas.openxmlformats.org/drawingml/2006/main"/>
           <a:p xmlns:a="http://schemas.openxmlformats.org/drawingml/2006/main">
             <a:pPr algn="l">
+              <a:buNone/>
               <a:defRPr sz="1275" b="0">
                 <a:solidFill>
                   <a:srgbClr val="5E7483"/>
@@ -5717,6 +5775,7 @@
           <a:lstStyle xmlns:a="http://schemas.openxmlformats.org/drawingml/2006/main"/>
           <a:p xmlns:a="http://schemas.openxmlformats.org/drawingml/2006/main">
             <a:pPr algn="l">
+              <a:buNone/>
               <a:defRPr sz="900" b="1">
                 <a:solidFill>
                   <a:srgbClr val="0F766E"/>
@@ -5775,6 +5834,7 @@
           <a:lstStyle xmlns:a="http://schemas.openxmlformats.org/drawingml/2006/main"/>
           <a:p xmlns:a="http://schemas.openxmlformats.org/drawingml/2006/main">
             <a:pPr algn="l">
+              <a:buNone/>
               <a:defRPr sz="1650" b="1">
                 <a:solidFill>
                   <a:srgbClr val="063E62"/>
@@ -5833,6 +5893,7 @@
           <a:lstStyle xmlns:a="http://schemas.openxmlformats.org/drawingml/2006/main"/>
           <a:p xmlns:a="http://schemas.openxmlformats.org/drawingml/2006/main">
             <a:pPr algn="l">
+              <a:buNone/>
               <a:defRPr sz="1275" b="0">
                 <a:solidFill>
                   <a:srgbClr val="5E7483"/>
@@ -5926,6 +5987,7 @@
           <a:lstStyle xmlns:a="http://schemas.openxmlformats.org/drawingml/2006/main"/>
           <a:p xmlns:a="http://schemas.openxmlformats.org/drawingml/2006/main">
             <a:pPr algn="l">
+              <a:buNone/>
               <a:defRPr sz="900" b="1">
                 <a:solidFill>
                   <a:srgbClr val="0F766E"/>
@@ -5984,6 +6046,7 @@
           <a:lstStyle xmlns:a="http://schemas.openxmlformats.org/drawingml/2006/main"/>
           <a:p xmlns:a="http://schemas.openxmlformats.org/drawingml/2006/main">
             <a:pPr algn="l">
+              <a:buNone/>
               <a:defRPr sz="1650" b="1">
                 <a:solidFill>
                   <a:srgbClr val="063E62"/>
@@ -6042,6 +6105,7 @@
           <a:lstStyle xmlns:a="http://schemas.openxmlformats.org/drawingml/2006/main"/>
           <a:p xmlns:a="http://schemas.openxmlformats.org/drawingml/2006/main">
             <a:pPr algn="l">
+              <a:buNone/>
               <a:defRPr sz="1275" b="0">
                 <a:solidFill>
                   <a:srgbClr val="5E7483"/>
@@ -6100,6 +6164,7 @@
           <a:lstStyle xmlns:a="http://schemas.openxmlformats.org/drawingml/2006/main"/>
           <a:p xmlns:a="http://schemas.openxmlformats.org/drawingml/2006/main">
             <a:pPr algn="l">
+              <a:buNone/>
               <a:defRPr sz="750" b="1">
                 <a:solidFill>
                   <a:srgbClr val="5E7483"/>
@@ -6180,6 +6245,7 @@
           <a:lstStyle xmlns:a="http://schemas.openxmlformats.org/drawingml/2006/main"/>
           <a:p xmlns:a="http://schemas.openxmlformats.org/drawingml/2006/main">
             <a:pPr algn="l">
+              <a:buNone/>
               <a:defRPr sz="975" b="1">
                 <a:solidFill>
                   <a:srgbClr val="0F766E"/>
@@ -6238,6 +6304,7 @@
           <a:lstStyle xmlns:a="http://schemas.openxmlformats.org/drawingml/2006/main"/>
           <a:p xmlns:a="http://schemas.openxmlformats.org/drawingml/2006/main">
             <a:pPr algn="l">
+              <a:buNone/>
               <a:defRPr sz="2850" b="1">
                 <a:solidFill>
                   <a:srgbClr val="063E62"/>
@@ -6296,6 +6363,7 @@
           <a:lstStyle xmlns:a="http://schemas.openxmlformats.org/drawingml/2006/main"/>
           <a:p xmlns:a="http://schemas.openxmlformats.org/drawingml/2006/main">
             <a:pPr algn="r">
+              <a:buNone/>
               <a:defRPr sz="975" b="1">
                 <a:solidFill>
                   <a:srgbClr val="5E7483"/>
@@ -6389,6 +6457,7 @@
           <a:lstStyle xmlns:a="http://schemas.openxmlformats.org/drawingml/2006/main"/>
           <a:p xmlns:a="http://schemas.openxmlformats.org/drawingml/2006/main">
             <a:pPr algn="l">
+              <a:buNone/>
               <a:defRPr sz="1800" b="1">
                 <a:solidFill>
                   <a:srgbClr val="063E62"/>
@@ -6447,6 +6516,7 @@
           <a:lstStyle xmlns:a="http://schemas.openxmlformats.org/drawingml/2006/main"/>
           <a:p xmlns:a="http://schemas.openxmlformats.org/drawingml/2006/main">
             <a:pPr algn="l">
+              <a:buNone/>
               <a:defRPr sz="1350" b="1">
                 <a:solidFill>
                   <a:srgbClr val="0F766E"/>
@@ -6505,6 +6575,7 @@
           <a:lstStyle xmlns:a="http://schemas.openxmlformats.org/drawingml/2006/main"/>
           <a:p xmlns:a="http://schemas.openxmlformats.org/drawingml/2006/main">
             <a:pPr algn="l">
+              <a:buNone/>
               <a:defRPr sz="1200" b="0">
                 <a:solidFill>
                   <a:srgbClr val="5E7483"/>
@@ -6563,6 +6634,7 @@
           <a:lstStyle xmlns:a="http://schemas.openxmlformats.org/drawingml/2006/main"/>
           <a:p xmlns:a="http://schemas.openxmlformats.org/drawingml/2006/main">
             <a:pPr algn="l">
+              <a:buNone/>
               <a:defRPr sz="1350" b="1">
                 <a:solidFill>
                   <a:srgbClr val="0F766E"/>
@@ -6621,6 +6693,7 @@
           <a:lstStyle xmlns:a="http://schemas.openxmlformats.org/drawingml/2006/main"/>
           <a:p xmlns:a="http://schemas.openxmlformats.org/drawingml/2006/main">
             <a:pPr algn="l">
+              <a:buNone/>
               <a:defRPr sz="1200" b="0">
                 <a:solidFill>
                   <a:srgbClr val="5E7483"/>
@@ -6679,6 +6752,7 @@
           <a:lstStyle xmlns:a="http://schemas.openxmlformats.org/drawingml/2006/main"/>
           <a:p xmlns:a="http://schemas.openxmlformats.org/drawingml/2006/main">
             <a:pPr algn="l">
+              <a:buNone/>
               <a:defRPr sz="1350" b="1">
                 <a:solidFill>
                   <a:srgbClr val="0F766E"/>
@@ -6737,6 +6811,7 @@
           <a:lstStyle xmlns:a="http://schemas.openxmlformats.org/drawingml/2006/main"/>
           <a:p xmlns:a="http://schemas.openxmlformats.org/drawingml/2006/main">
             <a:pPr algn="l">
+              <a:buNone/>
               <a:defRPr sz="1200" b="0">
                 <a:solidFill>
                   <a:srgbClr val="5E7483"/>
@@ -6830,6 +6905,7 @@
           <a:lstStyle xmlns:a="http://schemas.openxmlformats.org/drawingml/2006/main"/>
           <a:p xmlns:a="http://schemas.openxmlformats.org/drawingml/2006/main">
             <a:pPr algn="l">
+              <a:buNone/>
               <a:defRPr sz="1800" b="1">
                 <a:solidFill>
                   <a:srgbClr val="063E62"/>
@@ -6888,6 +6964,7 @@
           <a:lstStyle xmlns:a="http://schemas.openxmlformats.org/drawingml/2006/main"/>
           <a:p xmlns:a="http://schemas.openxmlformats.org/drawingml/2006/main">
             <a:pPr algn="l">
+              <a:buNone/>
               <a:defRPr sz="1350" b="1">
                 <a:solidFill>
                   <a:srgbClr val="0F766E"/>
@@ -6946,6 +7023,7 @@
           <a:lstStyle xmlns:a="http://schemas.openxmlformats.org/drawingml/2006/main"/>
           <a:p xmlns:a="http://schemas.openxmlformats.org/drawingml/2006/main">
             <a:pPr algn="l">
+              <a:buNone/>
               <a:defRPr sz="1200" b="0">
                 <a:solidFill>
                   <a:srgbClr val="5E7483"/>
@@ -7004,6 +7082,7 @@
           <a:lstStyle xmlns:a="http://schemas.openxmlformats.org/drawingml/2006/main"/>
           <a:p xmlns:a="http://schemas.openxmlformats.org/drawingml/2006/main">
             <a:pPr algn="l">
+              <a:buNone/>
               <a:defRPr sz="1350" b="1">
                 <a:solidFill>
                   <a:srgbClr val="0F766E"/>
@@ -7062,6 +7141,7 @@
           <a:lstStyle xmlns:a="http://schemas.openxmlformats.org/drawingml/2006/main"/>
           <a:p xmlns:a="http://schemas.openxmlformats.org/drawingml/2006/main">
             <a:pPr algn="l">
+              <a:buNone/>
               <a:defRPr sz="1200" b="0">
                 <a:solidFill>
                   <a:srgbClr val="5E7483"/>
@@ -7120,6 +7200,7 @@
           <a:lstStyle xmlns:a="http://schemas.openxmlformats.org/drawingml/2006/main"/>
           <a:p xmlns:a="http://schemas.openxmlformats.org/drawingml/2006/main">
             <a:pPr algn="l">
+              <a:buNone/>
               <a:defRPr sz="1350" b="1">
                 <a:solidFill>
                   <a:srgbClr val="0F766E"/>
@@ -7178,6 +7259,7 @@
           <a:lstStyle xmlns:a="http://schemas.openxmlformats.org/drawingml/2006/main"/>
           <a:p xmlns:a="http://schemas.openxmlformats.org/drawingml/2006/main">
             <a:pPr algn="l">
+              <a:buNone/>
               <a:defRPr sz="1200" b="0">
                 <a:solidFill>
                   <a:srgbClr val="5E7483"/>
@@ -7271,6 +7353,7 @@
           <a:lstStyle xmlns:a="http://schemas.openxmlformats.org/drawingml/2006/main"/>
           <a:p xmlns:a="http://schemas.openxmlformats.org/drawingml/2006/main">
             <a:pPr algn="l">
+              <a:buNone/>
               <a:defRPr sz="1800" b="1">
                 <a:solidFill>
                   <a:srgbClr val="063E62"/>
@@ -7329,6 +7412,7 @@
           <a:lstStyle xmlns:a="http://schemas.openxmlformats.org/drawingml/2006/main"/>
           <a:p xmlns:a="http://schemas.openxmlformats.org/drawingml/2006/main">
             <a:pPr algn="l">
+              <a:buNone/>
               <a:defRPr sz="1350" b="1">
                 <a:solidFill>
                   <a:srgbClr val="0F766E"/>
@@ -7387,6 +7471,7 @@
           <a:lstStyle xmlns:a="http://schemas.openxmlformats.org/drawingml/2006/main"/>
           <a:p xmlns:a="http://schemas.openxmlformats.org/drawingml/2006/main">
             <a:pPr algn="l">
+              <a:buNone/>
               <a:defRPr sz="1200" b="0">
                 <a:solidFill>
                   <a:srgbClr val="5E7483"/>
@@ -7445,6 +7530,7 @@
           <a:lstStyle xmlns:a="http://schemas.openxmlformats.org/drawingml/2006/main"/>
           <a:p xmlns:a="http://schemas.openxmlformats.org/drawingml/2006/main">
             <a:pPr algn="l">
+              <a:buNone/>
               <a:defRPr sz="1350" b="1">
                 <a:solidFill>
                   <a:srgbClr val="0F766E"/>
@@ -7503,6 +7589,7 @@
           <a:lstStyle xmlns:a="http://schemas.openxmlformats.org/drawingml/2006/main"/>
           <a:p xmlns:a="http://schemas.openxmlformats.org/drawingml/2006/main">
             <a:pPr algn="l">
+              <a:buNone/>
               <a:defRPr sz="1200" b="0">
                 <a:solidFill>
                   <a:srgbClr val="5E7483"/>
@@ -7561,6 +7648,7 @@
           <a:lstStyle xmlns:a="http://schemas.openxmlformats.org/drawingml/2006/main"/>
           <a:p xmlns:a="http://schemas.openxmlformats.org/drawingml/2006/main">
             <a:pPr algn="l">
+              <a:buNone/>
               <a:defRPr sz="1350" b="1">
                 <a:solidFill>
                   <a:srgbClr val="0F766E"/>
@@ -7619,6 +7707,7 @@
           <a:lstStyle xmlns:a="http://schemas.openxmlformats.org/drawingml/2006/main"/>
           <a:p xmlns:a="http://schemas.openxmlformats.org/drawingml/2006/main">
             <a:pPr algn="l">
+              <a:buNone/>
               <a:defRPr sz="1200" b="0">
                 <a:solidFill>
                   <a:srgbClr val="5E7483"/>
@@ -7677,6 +7766,7 @@
           <a:lstStyle xmlns:a="http://schemas.openxmlformats.org/drawingml/2006/main"/>
           <a:p xmlns:a="http://schemas.openxmlformats.org/drawingml/2006/main">
             <a:pPr algn="l">
+              <a:buNone/>
               <a:defRPr sz="750" b="1">
                 <a:solidFill>
                   <a:srgbClr val="5E7483"/>
@@ -7757,6 +7847,7 @@
           <a:lstStyle xmlns:a="http://schemas.openxmlformats.org/drawingml/2006/main"/>
           <a:p xmlns:a="http://schemas.openxmlformats.org/drawingml/2006/main">
             <a:pPr algn="l">
+              <a:buNone/>
               <a:defRPr sz="975" b="1">
                 <a:solidFill>
                   <a:srgbClr val="0F766E"/>
@@ -7815,6 +7906,7 @@
           <a:lstStyle xmlns:a="http://schemas.openxmlformats.org/drawingml/2006/main"/>
           <a:p xmlns:a="http://schemas.openxmlformats.org/drawingml/2006/main">
             <a:pPr algn="l">
+              <a:buNone/>
               <a:defRPr sz="2850" b="1">
                 <a:solidFill>
                   <a:srgbClr val="063E62"/>
@@ -7873,6 +7965,7 @@
           <a:lstStyle xmlns:a="http://schemas.openxmlformats.org/drawingml/2006/main"/>
           <a:p xmlns:a="http://schemas.openxmlformats.org/drawingml/2006/main">
             <a:pPr algn="r">
+              <a:buNone/>
               <a:defRPr sz="975" b="1">
                 <a:solidFill>
                   <a:srgbClr val="5E7483"/>
@@ -7898,14 +7991,14 @@
       </p:sp>
       <p:pic>
         <p:nvPicPr>
-          <p:cNvPr id="15" name=""/>
+          <p:cNvPr id="17" name=""/>
           <p:cNvPicPr>
             <a:picLocks xmlns:a="http://schemas.openxmlformats.org/drawingml/2006/main" noChangeAspect="1"/>
           </p:cNvPicPr>
           <p:nvPr/>
         </p:nvPicPr>
         <p:blipFill>
-          <a:blip xmlns:r="http://schemas.openxmlformats.org/officeDocument/2006/relationships" xmlns:a="http://schemas.openxmlformats.org/drawingml/2006/main" r:embed="R08731a0964aa4c03"/>
+          <a:blip xmlns:r="http://schemas.openxmlformats.org/officeDocument/2006/relationships" xmlns:a="http://schemas.openxmlformats.org/drawingml/2006/main" r:embed="R162d0001bbca44f2"/>
           <a:srcRect xmlns:a="http://schemas.openxmlformats.org/drawingml/2006/main" l="0" t="40265" r="0" b="40265"/>
           <a:stretch xmlns:a="http://schemas.openxmlformats.org/drawingml/2006/main">
             <a:fillRect l="0" t="0" r="0" b="0"/>
@@ -7958,6 +8051,7 @@
           <a:lstStyle xmlns:a="http://schemas.openxmlformats.org/drawingml/2006/main"/>
           <a:p xmlns:a="http://schemas.openxmlformats.org/drawingml/2006/main">
             <a:pPr algn="l">
+              <a:buNone/>
               <a:defRPr sz="1500" b="1">
                 <a:solidFill>
                   <a:srgbClr val="063E62"/>
@@ -8016,6 +8110,7 @@
           <a:lstStyle xmlns:a="http://schemas.openxmlformats.org/drawingml/2006/main"/>
           <a:p xmlns:a="http://schemas.openxmlformats.org/drawingml/2006/main">
             <a:pPr algn="l">
+              <a:buNone/>
               <a:defRPr sz="1200" b="0">
                 <a:solidFill>
                   <a:srgbClr val="5E7483"/>
@@ -8074,6 +8169,7 @@
           <a:lstStyle xmlns:a="http://schemas.openxmlformats.org/drawingml/2006/main"/>
           <a:p xmlns:a="http://schemas.openxmlformats.org/drawingml/2006/main">
             <a:pPr algn="l">
+              <a:buNone/>
               <a:defRPr sz="1500" b="1">
                 <a:solidFill>
                   <a:srgbClr val="063E62"/>
@@ -8132,6 +8228,7 @@
           <a:lstStyle xmlns:a="http://schemas.openxmlformats.org/drawingml/2006/main"/>
           <a:p xmlns:a="http://schemas.openxmlformats.org/drawingml/2006/main">
             <a:pPr algn="l">
+              <a:buNone/>
               <a:defRPr sz="1200" b="0">
                 <a:solidFill>
                   <a:srgbClr val="5E7483"/>
@@ -8190,6 +8287,7 @@
           <a:lstStyle xmlns:a="http://schemas.openxmlformats.org/drawingml/2006/main"/>
           <a:p xmlns:a="http://schemas.openxmlformats.org/drawingml/2006/main">
             <a:pPr algn="l">
+              <a:buNone/>
               <a:defRPr sz="1500" b="1">
                 <a:solidFill>
                   <a:srgbClr val="063E62"/>
@@ -8248,6 +8346,7 @@
           <a:lstStyle xmlns:a="http://schemas.openxmlformats.org/drawingml/2006/main"/>
           <a:p xmlns:a="http://schemas.openxmlformats.org/drawingml/2006/main">
             <a:pPr algn="l">
+              <a:buNone/>
               <a:defRPr sz="1200" b="0">
                 <a:solidFill>
                   <a:srgbClr val="5E7483"/>
@@ -8306,6 +8405,7 @@
           <a:lstStyle xmlns:a="http://schemas.openxmlformats.org/drawingml/2006/main"/>
           <a:p xmlns:a="http://schemas.openxmlformats.org/drawingml/2006/main">
             <a:pPr algn="l">
+              <a:buNone/>
               <a:defRPr sz="750" b="1">
                 <a:solidFill>
                   <a:srgbClr val="5E7483"/>
@@ -8360,14 +8460,14 @@
       </p:grpSpPr>
       <p:pic>
         <p:nvPicPr>
-          <p:cNvPr id="8" name=""/>
+          <p:cNvPr id="9" name=""/>
           <p:cNvPicPr>
             <a:picLocks xmlns:a="http://schemas.openxmlformats.org/drawingml/2006/main" noChangeAspect="1"/>
           </p:cNvPicPr>
           <p:nvPr/>
         </p:nvPicPr>
         <p:blipFill>
-          <a:blip xmlns:r="http://schemas.openxmlformats.org/officeDocument/2006/relationships" xmlns:a="http://schemas.openxmlformats.org/drawingml/2006/main" r:embed="R633bf23095f848a3"/>
+          <a:blip xmlns:r="http://schemas.openxmlformats.org/officeDocument/2006/relationships" xmlns:a="http://schemas.openxmlformats.org/drawingml/2006/main" r:embed="Rf84dfce15f17453f"/>
           <a:stretch xmlns:a="http://schemas.openxmlformats.org/drawingml/2006/main"/>
         </p:blipFill>
         <p:spPr>
@@ -8417,6 +8517,7 @@
           <a:lstStyle xmlns:a="http://schemas.openxmlformats.org/drawingml/2006/main"/>
           <a:p xmlns:a="http://schemas.openxmlformats.org/drawingml/2006/main">
             <a:pPr algn="l">
+              <a:buNone/>
               <a:defRPr sz="3750" b="1">
                 <a:solidFill>
                   <a:srgbClr val="FFFFFF"/>
@@ -8440,6 +8541,7 @@
           </a:p>
           <a:p xmlns:a="http://schemas.openxmlformats.org/drawingml/2006/main">
             <a:pPr algn="l">
+              <a:buNone/>
               <a:defRPr sz="3750" b="1">
                 <a:solidFill>
                   <a:srgbClr val="FFFFFF"/>
@@ -8498,6 +8600,7 @@
           <a:lstStyle xmlns:a="http://schemas.openxmlformats.org/drawingml/2006/main"/>
           <a:p xmlns:a="http://schemas.openxmlformats.org/drawingml/2006/main">
             <a:pPr algn="l">
+              <a:buNone/>
               <a:defRPr sz="1575" b="0">
                 <a:solidFill>
                   <a:srgbClr val="CBE7ED"/>
@@ -8593,6 +8696,7 @@
           <a:lstStyle xmlns:a="http://schemas.openxmlformats.org/drawingml/2006/main"/>
           <a:p xmlns:a="http://schemas.openxmlformats.org/drawingml/2006/main">
             <a:pPr algn="l">
+              <a:buNone/>
               <a:defRPr sz="1725" b="1">
                 <a:solidFill>
                   <a:srgbClr val="FFFFFF"/>
@@ -8651,6 +8755,7 @@
           <a:lstStyle xmlns:a="http://schemas.openxmlformats.org/drawingml/2006/main"/>
           <a:p xmlns:a="http://schemas.openxmlformats.org/drawingml/2006/main">
             <a:pPr algn="l">
+              <a:buNone/>
               <a:defRPr sz="1350" b="0">
                 <a:solidFill>
                   <a:srgbClr val="D8EEF4"/>
@@ -8679,6 +8784,7 @@
           </a:p>
           <a:p xmlns:a="http://schemas.openxmlformats.org/drawingml/2006/main">
             <a:pPr algn="l">
+              <a:buNone/>
               <a:defRPr sz="1350" b="0">
                 <a:solidFill>
                   <a:srgbClr val="D8EEF4"/>
@@ -8707,6 +8813,7 @@
           </a:p>
           <a:p xmlns:a="http://schemas.openxmlformats.org/drawingml/2006/main">
             <a:pPr algn="l">
+              <a:buNone/>
               <a:defRPr sz="1350" b="0">
                 <a:solidFill>
                   <a:srgbClr val="D8EEF4"/>
@@ -8735,6 +8842,7 @@
           </a:p>
           <a:p xmlns:a="http://schemas.openxmlformats.org/drawingml/2006/main">
             <a:pPr algn="l">
+              <a:buNone/>
               <a:defRPr sz="1350" b="0">
                 <a:solidFill>
                   <a:srgbClr val="D8EEF4"/>
@@ -8793,6 +8901,7 @@
           <a:lstStyle xmlns:a="http://schemas.openxmlformats.org/drawingml/2006/main"/>
           <a:p xmlns:a="http://schemas.openxmlformats.org/drawingml/2006/main">
             <a:pPr algn="l">
+              <a:buNone/>
               <a:defRPr sz="975" b="1">
                 <a:solidFill>
                   <a:srgbClr val="90C8D4"/>
@@ -8811,7 +8920,7 @@
                 <a:ea typeface="Aptos"/>
                 <a:cs typeface="Aptos"/>
               </a:rPr>
-              <a:t>My ThreatLens · Arsen Eliane · 2026</a:t>
+              <a:t>My ThreatLens · 2026</a:t>
             </a:r>
           </a:p>
         </p:txBody>
@@ -8873,6 +8982,7 @@
           <a:lstStyle xmlns:a="http://schemas.openxmlformats.org/drawingml/2006/main"/>
           <a:p xmlns:a="http://schemas.openxmlformats.org/drawingml/2006/main">
             <a:pPr algn="l">
+              <a:buNone/>
               <a:defRPr sz="975" b="1">
                 <a:solidFill>
                   <a:srgbClr val="0F766E"/>
@@ -8931,6 +9041,7 @@
           <a:lstStyle xmlns:a="http://schemas.openxmlformats.org/drawingml/2006/main"/>
           <a:p xmlns:a="http://schemas.openxmlformats.org/drawingml/2006/main">
             <a:pPr algn="l">
+              <a:buNone/>
               <a:defRPr sz="2850" b="1">
                 <a:solidFill>
                   <a:srgbClr val="063E62"/>
@@ -8989,6 +9100,7 @@
           <a:lstStyle xmlns:a="http://schemas.openxmlformats.org/drawingml/2006/main"/>
           <a:p xmlns:a="http://schemas.openxmlformats.org/drawingml/2006/main">
             <a:pPr algn="r">
+              <a:buNone/>
               <a:defRPr sz="975" b="1">
                 <a:solidFill>
                   <a:srgbClr val="5E7483"/>
@@ -9082,6 +9194,7 @@
           <a:lstStyle xmlns:a="http://schemas.openxmlformats.org/drawingml/2006/main"/>
           <a:p xmlns:a="http://schemas.openxmlformats.org/drawingml/2006/main">
             <a:pPr algn="l">
+              <a:buNone/>
               <a:defRPr sz="1050" b="1">
                 <a:solidFill>
                   <a:srgbClr val="0F766E"/>
@@ -9140,6 +9253,7 @@
           <a:lstStyle xmlns:a="http://schemas.openxmlformats.org/drawingml/2006/main"/>
           <a:p xmlns:a="http://schemas.openxmlformats.org/drawingml/2006/main">
             <a:pPr algn="l">
+              <a:buNone/>
               <a:defRPr sz="2025" b="1">
                 <a:solidFill>
                   <a:srgbClr val="063E62"/>
@@ -9198,6 +9312,7 @@
           <a:lstStyle xmlns:a="http://schemas.openxmlformats.org/drawingml/2006/main"/>
           <a:p xmlns:a="http://schemas.openxmlformats.org/drawingml/2006/main">
             <a:pPr algn="l">
+              <a:buNone/>
               <a:defRPr sz="1350" b="0">
                 <a:solidFill>
                   <a:srgbClr val="5E7483"/>
@@ -9291,6 +9406,7 @@
           <a:lstStyle xmlns:a="http://schemas.openxmlformats.org/drawingml/2006/main"/>
           <a:p xmlns:a="http://schemas.openxmlformats.org/drawingml/2006/main">
             <a:pPr algn="l">
+              <a:buNone/>
               <a:defRPr sz="1050" b="1">
                 <a:solidFill>
                   <a:srgbClr val="0F766E"/>
@@ -9349,6 +9465,7 @@
           <a:lstStyle xmlns:a="http://schemas.openxmlformats.org/drawingml/2006/main"/>
           <a:p xmlns:a="http://schemas.openxmlformats.org/drawingml/2006/main">
             <a:pPr algn="l">
+              <a:buNone/>
               <a:defRPr sz="2025" b="1">
                 <a:solidFill>
                   <a:srgbClr val="063E62"/>
@@ -9407,6 +9524,7 @@
           <a:lstStyle xmlns:a="http://schemas.openxmlformats.org/drawingml/2006/main"/>
           <a:p xmlns:a="http://schemas.openxmlformats.org/drawingml/2006/main">
             <a:pPr algn="l">
+              <a:buNone/>
               <a:defRPr sz="1350" b="0">
                 <a:solidFill>
                   <a:srgbClr val="5E7483"/>
@@ -9500,6 +9618,7 @@
           <a:lstStyle xmlns:a="http://schemas.openxmlformats.org/drawingml/2006/main"/>
           <a:p xmlns:a="http://schemas.openxmlformats.org/drawingml/2006/main">
             <a:pPr algn="l">
+              <a:buNone/>
               <a:defRPr sz="1050" b="1">
                 <a:solidFill>
                   <a:srgbClr val="0F766E"/>
@@ -9558,6 +9677,7 @@
           <a:lstStyle xmlns:a="http://schemas.openxmlformats.org/drawingml/2006/main"/>
           <a:p xmlns:a="http://schemas.openxmlformats.org/drawingml/2006/main">
             <a:pPr algn="l">
+              <a:buNone/>
               <a:defRPr sz="2025" b="1">
                 <a:solidFill>
                   <a:srgbClr val="063E62"/>
@@ -9616,6 +9736,7 @@
           <a:lstStyle xmlns:a="http://schemas.openxmlformats.org/drawingml/2006/main"/>
           <a:p xmlns:a="http://schemas.openxmlformats.org/drawingml/2006/main">
             <a:pPr algn="l">
+              <a:buNone/>
               <a:defRPr sz="1350" b="0">
                 <a:solidFill>
                   <a:srgbClr val="5E7483"/>
@@ -9709,6 +9830,7 @@
           <a:lstStyle xmlns:a="http://schemas.openxmlformats.org/drawingml/2006/main"/>
           <a:p xmlns:a="http://schemas.openxmlformats.org/drawingml/2006/main">
             <a:pPr algn="l">
+              <a:buNone/>
               <a:defRPr sz="1050" b="1">
                 <a:solidFill>
                   <a:srgbClr val="0F766E"/>
@@ -9767,6 +9889,7 @@
           <a:lstStyle xmlns:a="http://schemas.openxmlformats.org/drawingml/2006/main"/>
           <a:p xmlns:a="http://schemas.openxmlformats.org/drawingml/2006/main">
             <a:pPr algn="l">
+              <a:buNone/>
               <a:defRPr sz="2025" b="1">
                 <a:solidFill>
                   <a:srgbClr val="063E62"/>
@@ -9825,6 +9948,7 @@
           <a:lstStyle xmlns:a="http://schemas.openxmlformats.org/drawingml/2006/main"/>
           <a:p xmlns:a="http://schemas.openxmlformats.org/drawingml/2006/main">
             <a:pPr algn="l">
+              <a:buNone/>
               <a:defRPr sz="1350" b="0">
                 <a:solidFill>
                   <a:srgbClr val="5E7483"/>
@@ -9883,6 +10007,7 @@
           <a:lstStyle xmlns:a="http://schemas.openxmlformats.org/drawingml/2006/main"/>
           <a:p xmlns:a="http://schemas.openxmlformats.org/drawingml/2006/main">
             <a:pPr algn="l">
+              <a:buNone/>
               <a:defRPr sz="750" b="1">
                 <a:solidFill>
                   <a:srgbClr val="5E7483"/>
@@ -9963,6 +10088,7 @@
           <a:lstStyle xmlns:a="http://schemas.openxmlformats.org/drawingml/2006/main"/>
           <a:p xmlns:a="http://schemas.openxmlformats.org/drawingml/2006/main">
             <a:pPr algn="l">
+              <a:buNone/>
               <a:defRPr sz="975" b="1">
                 <a:solidFill>
                   <a:srgbClr val="0F766E"/>
@@ -10021,6 +10147,7 @@
           <a:lstStyle xmlns:a="http://schemas.openxmlformats.org/drawingml/2006/main"/>
           <a:p xmlns:a="http://schemas.openxmlformats.org/drawingml/2006/main">
             <a:pPr algn="l">
+              <a:buNone/>
               <a:defRPr sz="2850" b="1">
                 <a:solidFill>
                   <a:srgbClr val="063E62"/>
@@ -10079,6 +10206,7 @@
           <a:lstStyle xmlns:a="http://schemas.openxmlformats.org/drawingml/2006/main"/>
           <a:p xmlns:a="http://schemas.openxmlformats.org/drawingml/2006/main">
             <a:pPr algn="r">
+              <a:buNone/>
               <a:defRPr sz="975" b="1">
                 <a:solidFill>
                   <a:srgbClr val="5E7483"/>
@@ -10104,14 +10232,14 @@
       </p:sp>
       <p:pic>
         <p:nvPicPr>
-          <p:cNvPr id="17" name=""/>
+          <p:cNvPr id="19" name=""/>
           <p:cNvPicPr>
             <a:picLocks xmlns:a="http://schemas.openxmlformats.org/drawingml/2006/main" noChangeAspect="1"/>
           </p:cNvPicPr>
           <p:nvPr/>
         </p:nvPicPr>
         <p:blipFill>
-          <a:blip xmlns:r="http://schemas.openxmlformats.org/officeDocument/2006/relationships" xmlns:a="http://schemas.openxmlformats.org/drawingml/2006/main" r:embed="Re712ce78efd342dd"/>
+          <a:blip xmlns:r="http://schemas.openxmlformats.org/officeDocument/2006/relationships" xmlns:a="http://schemas.openxmlformats.org/drawingml/2006/main" r:embed="R2118ac70d74b44e8"/>
           <a:stretch xmlns:a="http://schemas.openxmlformats.org/drawingml/2006/main"/>
         </p:blipFill>
         <p:spPr>
@@ -10196,6 +10324,7 @@
           <a:lstStyle xmlns:a="http://schemas.openxmlformats.org/drawingml/2006/main"/>
           <a:p xmlns:a="http://schemas.openxmlformats.org/drawingml/2006/main">
             <a:pPr algn="l">
+              <a:buNone/>
               <a:defRPr sz="1950" b="1">
                 <a:solidFill>
                   <a:srgbClr val="FFFFFF"/>
@@ -10254,6 +10383,7 @@
           <a:lstStyle xmlns:a="http://schemas.openxmlformats.org/drawingml/2006/main"/>
           <a:p xmlns:a="http://schemas.openxmlformats.org/drawingml/2006/main">
             <a:pPr algn="l">
+              <a:buNone/>
               <a:defRPr sz="1500" b="1">
                 <a:solidFill>
                   <a:srgbClr val="FFFFFF"/>
@@ -10312,6 +10442,7 @@
           <a:lstStyle xmlns:a="http://schemas.openxmlformats.org/drawingml/2006/main"/>
           <a:p xmlns:a="http://schemas.openxmlformats.org/drawingml/2006/main">
             <a:pPr algn="l">
+              <a:buNone/>
               <a:defRPr sz="1200" b="0">
                 <a:solidFill>
                   <a:srgbClr val="D8EEF4"/>
@@ -10370,6 +10501,7 @@
           <a:lstStyle xmlns:a="http://schemas.openxmlformats.org/drawingml/2006/main"/>
           <a:p xmlns:a="http://schemas.openxmlformats.org/drawingml/2006/main">
             <a:pPr algn="l">
+              <a:buNone/>
               <a:defRPr sz="1500" b="1">
                 <a:solidFill>
                   <a:srgbClr val="FFFFFF"/>
@@ -10428,6 +10560,7 @@
           <a:lstStyle xmlns:a="http://schemas.openxmlformats.org/drawingml/2006/main"/>
           <a:p xmlns:a="http://schemas.openxmlformats.org/drawingml/2006/main">
             <a:pPr algn="l">
+              <a:buNone/>
               <a:defRPr sz="1200" b="0">
                 <a:solidFill>
                   <a:srgbClr val="D8EEF4"/>
@@ -10486,6 +10619,7 @@
           <a:lstStyle xmlns:a="http://schemas.openxmlformats.org/drawingml/2006/main"/>
           <a:p xmlns:a="http://schemas.openxmlformats.org/drawingml/2006/main">
             <a:pPr algn="l">
+              <a:buNone/>
               <a:defRPr sz="1500" b="1">
                 <a:solidFill>
                   <a:srgbClr val="FFFFFF"/>
@@ -10544,6 +10678,7 @@
           <a:lstStyle xmlns:a="http://schemas.openxmlformats.org/drawingml/2006/main"/>
           <a:p xmlns:a="http://schemas.openxmlformats.org/drawingml/2006/main">
             <a:pPr algn="l">
+              <a:buNone/>
               <a:defRPr sz="1200" b="0">
                 <a:solidFill>
                   <a:srgbClr val="D8EEF4"/>
@@ -10602,6 +10737,7 @@
           <a:lstStyle xmlns:a="http://schemas.openxmlformats.org/drawingml/2006/main"/>
           <a:p xmlns:a="http://schemas.openxmlformats.org/drawingml/2006/main">
             <a:pPr algn="l">
+              <a:buNone/>
               <a:defRPr sz="750" b="1">
                 <a:solidFill>
                   <a:srgbClr val="5E7483"/>
@@ -10682,6 +10818,7 @@
           <a:lstStyle xmlns:a="http://schemas.openxmlformats.org/drawingml/2006/main"/>
           <a:p xmlns:a="http://schemas.openxmlformats.org/drawingml/2006/main">
             <a:pPr algn="l">
+              <a:buNone/>
               <a:defRPr sz="975" b="1">
                 <a:solidFill>
                   <a:srgbClr val="0F766E"/>
@@ -10740,6 +10877,7 @@
           <a:lstStyle xmlns:a="http://schemas.openxmlformats.org/drawingml/2006/main"/>
           <a:p xmlns:a="http://schemas.openxmlformats.org/drawingml/2006/main">
             <a:pPr algn="l">
+              <a:buNone/>
               <a:defRPr sz="2850" b="1">
                 <a:solidFill>
                   <a:srgbClr val="063E62"/>
@@ -10798,6 +10936,7 @@
           <a:lstStyle xmlns:a="http://schemas.openxmlformats.org/drawingml/2006/main"/>
           <a:p xmlns:a="http://schemas.openxmlformats.org/drawingml/2006/main">
             <a:pPr algn="r">
+              <a:buNone/>
               <a:defRPr sz="975" b="1">
                 <a:solidFill>
                   <a:srgbClr val="5E7483"/>
@@ -10823,7 +10962,7 @@
       </p:sp>
       <p:cxnSp>
         <p:nvCxnSpPr>
-          <p:cNvPr id="25" name=""/>
+          <p:cNvPr id="29" name=""/>
           <p:cNvCxnSpPr/>
           <p:nvPr/>
         </p:nvCxnSpPr>
@@ -10911,6 +11050,7 @@
           <a:lstStyle xmlns:a="http://schemas.openxmlformats.org/drawingml/2006/main"/>
           <a:p xmlns:a="http://schemas.openxmlformats.org/drawingml/2006/main">
             <a:pPr algn="l">
+              <a:buNone/>
               <a:defRPr sz="1050" b="1">
                 <a:solidFill>
                   <a:srgbClr val="0F766E"/>
@@ -10969,6 +11109,7 @@
           <a:lstStyle xmlns:a="http://schemas.openxmlformats.org/drawingml/2006/main"/>
           <a:p xmlns:a="http://schemas.openxmlformats.org/drawingml/2006/main">
             <a:pPr algn="l">
+              <a:buNone/>
               <a:defRPr sz="1575" b="1">
                 <a:solidFill>
                   <a:srgbClr val="063E62"/>
@@ -11027,6 +11168,7 @@
           <a:lstStyle xmlns:a="http://schemas.openxmlformats.org/drawingml/2006/main"/>
           <a:p xmlns:a="http://schemas.openxmlformats.org/drawingml/2006/main">
             <a:pPr algn="l">
+              <a:buNone/>
               <a:defRPr sz="1200" b="0">
                 <a:solidFill>
                   <a:srgbClr val="5E7483"/>
@@ -11118,6 +11260,7 @@
           <a:lstStyle xmlns:a="http://schemas.openxmlformats.org/drawingml/2006/main"/>
           <a:p xmlns:a="http://schemas.openxmlformats.org/drawingml/2006/main">
             <a:pPr algn="l">
+              <a:buNone/>
               <a:defRPr sz="1050" b="1">
                 <a:solidFill>
                   <a:srgbClr val="0F766E"/>
@@ -11176,6 +11319,7 @@
           <a:lstStyle xmlns:a="http://schemas.openxmlformats.org/drawingml/2006/main"/>
           <a:p xmlns:a="http://schemas.openxmlformats.org/drawingml/2006/main">
             <a:pPr algn="l">
+              <a:buNone/>
               <a:defRPr sz="1575" b="1">
                 <a:solidFill>
                   <a:srgbClr val="063E62"/>
@@ -11234,6 +11378,7 @@
           <a:lstStyle xmlns:a="http://schemas.openxmlformats.org/drawingml/2006/main"/>
           <a:p xmlns:a="http://schemas.openxmlformats.org/drawingml/2006/main">
             <a:pPr algn="l">
+              <a:buNone/>
               <a:defRPr sz="1200" b="0">
                 <a:solidFill>
                   <a:srgbClr val="5E7483"/>
@@ -11325,6 +11470,7 @@
           <a:lstStyle xmlns:a="http://schemas.openxmlformats.org/drawingml/2006/main"/>
           <a:p xmlns:a="http://schemas.openxmlformats.org/drawingml/2006/main">
             <a:pPr algn="l">
+              <a:buNone/>
               <a:defRPr sz="1050" b="1">
                 <a:solidFill>
                   <a:srgbClr val="0F766E"/>
@@ -11383,6 +11529,7 @@
           <a:lstStyle xmlns:a="http://schemas.openxmlformats.org/drawingml/2006/main"/>
           <a:p xmlns:a="http://schemas.openxmlformats.org/drawingml/2006/main">
             <a:pPr algn="l">
+              <a:buNone/>
               <a:defRPr sz="1575" b="1">
                 <a:solidFill>
                   <a:srgbClr val="063E62"/>
@@ -11441,6 +11588,7 @@
           <a:lstStyle xmlns:a="http://schemas.openxmlformats.org/drawingml/2006/main"/>
           <a:p xmlns:a="http://schemas.openxmlformats.org/drawingml/2006/main">
             <a:pPr algn="l">
+              <a:buNone/>
               <a:defRPr sz="1200" b="0">
                 <a:solidFill>
                   <a:srgbClr val="5E7483"/>
@@ -11532,6 +11680,7 @@
           <a:lstStyle xmlns:a="http://schemas.openxmlformats.org/drawingml/2006/main"/>
           <a:p xmlns:a="http://schemas.openxmlformats.org/drawingml/2006/main">
             <a:pPr algn="l">
+              <a:buNone/>
               <a:defRPr sz="1050" b="1">
                 <a:solidFill>
                   <a:srgbClr val="0F766E"/>
@@ -11590,6 +11739,7 @@
           <a:lstStyle xmlns:a="http://schemas.openxmlformats.org/drawingml/2006/main"/>
           <a:p xmlns:a="http://schemas.openxmlformats.org/drawingml/2006/main">
             <a:pPr algn="l">
+              <a:buNone/>
               <a:defRPr sz="1575" b="1">
                 <a:solidFill>
                   <a:srgbClr val="063E62"/>
@@ -11648,6 +11798,7 @@
           <a:lstStyle xmlns:a="http://schemas.openxmlformats.org/drawingml/2006/main"/>
           <a:p xmlns:a="http://schemas.openxmlformats.org/drawingml/2006/main">
             <a:pPr algn="l">
+              <a:buNone/>
               <a:defRPr sz="1200" b="0">
                 <a:solidFill>
                   <a:srgbClr val="5E7483"/>
@@ -11706,6 +11857,7 @@
           <a:lstStyle xmlns:a="http://schemas.openxmlformats.org/drawingml/2006/main"/>
           <a:p xmlns:a="http://schemas.openxmlformats.org/drawingml/2006/main">
             <a:pPr algn="l">
+              <a:buNone/>
               <a:defRPr sz="750" b="1">
                 <a:solidFill>
                   <a:srgbClr val="5E7483"/>
@@ -11786,6 +11938,7 @@
           <a:lstStyle xmlns:a="http://schemas.openxmlformats.org/drawingml/2006/main"/>
           <a:p xmlns:a="http://schemas.openxmlformats.org/drawingml/2006/main">
             <a:pPr algn="l">
+              <a:buNone/>
               <a:defRPr sz="975" b="1">
                 <a:solidFill>
                   <a:srgbClr val="0F766E"/>
@@ -11844,6 +11997,7 @@
           <a:lstStyle xmlns:a="http://schemas.openxmlformats.org/drawingml/2006/main"/>
           <a:p xmlns:a="http://schemas.openxmlformats.org/drawingml/2006/main">
             <a:pPr algn="l">
+              <a:buNone/>
               <a:defRPr sz="2850" b="1">
                 <a:solidFill>
                   <a:srgbClr val="063E62"/>
@@ -11902,6 +12056,7 @@
           <a:lstStyle xmlns:a="http://schemas.openxmlformats.org/drawingml/2006/main"/>
           <a:p xmlns:a="http://schemas.openxmlformats.org/drawingml/2006/main">
             <a:pPr algn="r">
+              <a:buNone/>
               <a:defRPr sz="975" b="1">
                 <a:solidFill>
                   <a:srgbClr val="5E7483"/>
@@ -11927,14 +12082,14 @@
       </p:sp>
       <p:pic>
         <p:nvPicPr>
-          <p:cNvPr id="18" name=""/>
+          <p:cNvPr id="20" name=""/>
           <p:cNvPicPr>
             <a:picLocks xmlns:a="http://schemas.openxmlformats.org/drawingml/2006/main" noChangeAspect="1"/>
           </p:cNvPicPr>
           <p:nvPr/>
         </p:nvPicPr>
         <p:blipFill>
-          <a:blip xmlns:r="http://schemas.openxmlformats.org/officeDocument/2006/relationships" xmlns:a="http://schemas.openxmlformats.org/drawingml/2006/main" r:embed="Rc50eae747a7e45bc"/>
+          <a:blip xmlns:r="http://schemas.openxmlformats.org/officeDocument/2006/relationships" xmlns:a="http://schemas.openxmlformats.org/drawingml/2006/main" r:embed="Rf5f913c772fc43eb"/>
           <a:srcRect xmlns:a="http://schemas.openxmlformats.org/drawingml/2006/main" l="2697" t="0" r="2697" b="0"/>
           <a:stretch xmlns:a="http://schemas.openxmlformats.org/drawingml/2006/main">
             <a:fillRect l="0" t="0" r="0" b="0"/>
@@ -12022,6 +12177,7 @@
           <a:lstStyle xmlns:a="http://schemas.openxmlformats.org/drawingml/2006/main"/>
           <a:p xmlns:a="http://schemas.openxmlformats.org/drawingml/2006/main">
             <a:pPr algn="l">
+              <a:buNone/>
               <a:defRPr sz="1500" b="1">
                 <a:solidFill>
                   <a:srgbClr val="063E62"/>
@@ -12080,6 +12236,7 @@
           <a:lstStyle xmlns:a="http://schemas.openxmlformats.org/drawingml/2006/main"/>
           <a:p xmlns:a="http://schemas.openxmlformats.org/drawingml/2006/main">
             <a:pPr algn="l">
+              <a:buNone/>
               <a:defRPr sz="1200" b="0">
                 <a:solidFill>
                   <a:srgbClr val="5E7483"/>
@@ -12173,6 +12330,7 @@
           <a:lstStyle xmlns:a="http://schemas.openxmlformats.org/drawingml/2006/main"/>
           <a:p xmlns:a="http://schemas.openxmlformats.org/drawingml/2006/main">
             <a:pPr algn="l">
+              <a:buNone/>
               <a:defRPr sz="1500" b="1">
                 <a:solidFill>
                   <a:srgbClr val="063E62"/>
@@ -12231,6 +12389,7 @@
           <a:lstStyle xmlns:a="http://schemas.openxmlformats.org/drawingml/2006/main"/>
           <a:p xmlns:a="http://schemas.openxmlformats.org/drawingml/2006/main">
             <a:pPr algn="l">
+              <a:buNone/>
               <a:defRPr sz="1200" b="0">
                 <a:solidFill>
                   <a:srgbClr val="5E7483"/>
@@ -12324,6 +12483,7 @@
           <a:lstStyle xmlns:a="http://schemas.openxmlformats.org/drawingml/2006/main"/>
           <a:p xmlns:a="http://schemas.openxmlformats.org/drawingml/2006/main">
             <a:pPr algn="l">
+              <a:buNone/>
               <a:defRPr sz="1500" b="1">
                 <a:solidFill>
                   <a:srgbClr val="063E62"/>
@@ -12382,6 +12542,7 @@
           <a:lstStyle xmlns:a="http://schemas.openxmlformats.org/drawingml/2006/main"/>
           <a:p xmlns:a="http://schemas.openxmlformats.org/drawingml/2006/main">
             <a:pPr algn="l">
+              <a:buNone/>
               <a:defRPr sz="1200" b="0">
                 <a:solidFill>
                   <a:srgbClr val="5E7483"/>
@@ -12440,6 +12601,7 @@
           <a:lstStyle xmlns:a="http://schemas.openxmlformats.org/drawingml/2006/main"/>
           <a:p xmlns:a="http://schemas.openxmlformats.org/drawingml/2006/main">
             <a:pPr algn="l">
+              <a:buNone/>
               <a:defRPr sz="750" b="1">
                 <a:solidFill>
                   <a:srgbClr val="5E7483"/>
@@ -12520,6 +12682,7 @@
           <a:lstStyle xmlns:a="http://schemas.openxmlformats.org/drawingml/2006/main"/>
           <a:p xmlns:a="http://schemas.openxmlformats.org/drawingml/2006/main">
             <a:pPr algn="l">
+              <a:buNone/>
               <a:defRPr sz="975" b="1">
                 <a:solidFill>
                   <a:srgbClr val="0F766E"/>
@@ -12578,6 +12741,7 @@
           <a:lstStyle xmlns:a="http://schemas.openxmlformats.org/drawingml/2006/main"/>
           <a:p xmlns:a="http://schemas.openxmlformats.org/drawingml/2006/main">
             <a:pPr algn="l">
+              <a:buNone/>
               <a:defRPr sz="2850" b="1">
                 <a:solidFill>
                   <a:srgbClr val="063E62"/>
@@ -12636,6 +12800,7 @@
           <a:lstStyle xmlns:a="http://schemas.openxmlformats.org/drawingml/2006/main"/>
           <a:p xmlns:a="http://schemas.openxmlformats.org/drawingml/2006/main">
             <a:pPr algn="r">
+              <a:buNone/>
               <a:defRPr sz="975" b="1">
                 <a:solidFill>
                   <a:srgbClr val="5E7483"/>
@@ -12729,6 +12894,7 @@
           <a:lstStyle xmlns:a="http://schemas.openxmlformats.org/drawingml/2006/main"/>
           <a:p xmlns:a="http://schemas.openxmlformats.org/drawingml/2006/main">
             <a:pPr algn="l">
+              <a:buNone/>
               <a:defRPr sz="900" b="1">
                 <a:solidFill>
                   <a:srgbClr val="0F766E"/>
@@ -12787,6 +12953,7 @@
           <a:lstStyle xmlns:a="http://schemas.openxmlformats.org/drawingml/2006/main"/>
           <a:p xmlns:a="http://schemas.openxmlformats.org/drawingml/2006/main">
             <a:pPr algn="ctr">
+              <a:buNone/>
               <a:defRPr sz="1500" b="1">
                 <a:solidFill>
                   <a:srgbClr val="063E62"/>
@@ -12845,6 +13012,7 @@
           <a:lstStyle xmlns:a="http://schemas.openxmlformats.org/drawingml/2006/main"/>
           <a:p xmlns:a="http://schemas.openxmlformats.org/drawingml/2006/main">
             <a:pPr algn="ctr">
+              <a:buNone/>
               <a:defRPr sz="1800" b="1">
                 <a:solidFill>
                   <a:srgbClr val="0F766E"/>
@@ -12938,6 +13106,7 @@
           <a:lstStyle xmlns:a="http://schemas.openxmlformats.org/drawingml/2006/main"/>
           <a:p xmlns:a="http://schemas.openxmlformats.org/drawingml/2006/main">
             <a:pPr algn="l">
+              <a:buNone/>
               <a:defRPr sz="900" b="1">
                 <a:solidFill>
                   <a:srgbClr val="0F766E"/>
@@ -12996,6 +13165,7 @@
           <a:lstStyle xmlns:a="http://schemas.openxmlformats.org/drawingml/2006/main"/>
           <a:p xmlns:a="http://schemas.openxmlformats.org/drawingml/2006/main">
             <a:pPr algn="ctr">
+              <a:buNone/>
               <a:defRPr sz="1500" b="1">
                 <a:solidFill>
                   <a:srgbClr val="063E62"/>
@@ -13054,6 +13224,7 @@
           <a:lstStyle xmlns:a="http://schemas.openxmlformats.org/drawingml/2006/main"/>
           <a:p xmlns:a="http://schemas.openxmlformats.org/drawingml/2006/main">
             <a:pPr algn="ctr">
+              <a:buNone/>
               <a:defRPr sz="1800" b="1">
                 <a:solidFill>
                   <a:srgbClr val="0F766E"/>
@@ -13147,6 +13318,7 @@
           <a:lstStyle xmlns:a="http://schemas.openxmlformats.org/drawingml/2006/main"/>
           <a:p xmlns:a="http://schemas.openxmlformats.org/drawingml/2006/main">
             <a:pPr algn="l">
+              <a:buNone/>
               <a:defRPr sz="900" b="1">
                 <a:solidFill>
                   <a:srgbClr val="0F766E"/>
@@ -13205,6 +13377,7 @@
           <a:lstStyle xmlns:a="http://schemas.openxmlformats.org/drawingml/2006/main"/>
           <a:p xmlns:a="http://schemas.openxmlformats.org/drawingml/2006/main">
             <a:pPr algn="ctr">
+              <a:buNone/>
               <a:defRPr sz="1500" b="1">
                 <a:solidFill>
                   <a:srgbClr val="063E62"/>
@@ -13263,6 +13436,7 @@
           <a:lstStyle xmlns:a="http://schemas.openxmlformats.org/drawingml/2006/main"/>
           <a:p xmlns:a="http://schemas.openxmlformats.org/drawingml/2006/main">
             <a:pPr algn="ctr">
+              <a:buNone/>
               <a:defRPr sz="1800" b="1">
                 <a:solidFill>
                   <a:srgbClr val="0F766E"/>
@@ -13356,6 +13530,7 @@
           <a:lstStyle xmlns:a="http://schemas.openxmlformats.org/drawingml/2006/main"/>
           <a:p xmlns:a="http://schemas.openxmlformats.org/drawingml/2006/main">
             <a:pPr algn="l">
+              <a:buNone/>
               <a:defRPr sz="900" b="1">
                 <a:solidFill>
                   <a:srgbClr val="0F766E"/>
@@ -13414,6 +13589,7 @@
           <a:lstStyle xmlns:a="http://schemas.openxmlformats.org/drawingml/2006/main"/>
           <a:p xmlns:a="http://schemas.openxmlformats.org/drawingml/2006/main">
             <a:pPr algn="ctr">
+              <a:buNone/>
               <a:defRPr sz="1500" b="1">
                 <a:solidFill>
                   <a:srgbClr val="063E62"/>
@@ -13472,6 +13648,7 @@
           <a:lstStyle xmlns:a="http://schemas.openxmlformats.org/drawingml/2006/main"/>
           <a:p xmlns:a="http://schemas.openxmlformats.org/drawingml/2006/main">
             <a:pPr algn="ctr">
+              <a:buNone/>
               <a:defRPr sz="1800" b="1">
                 <a:solidFill>
                   <a:srgbClr val="0F766E"/>
@@ -13565,6 +13742,7 @@
           <a:lstStyle xmlns:a="http://schemas.openxmlformats.org/drawingml/2006/main"/>
           <a:p xmlns:a="http://schemas.openxmlformats.org/drawingml/2006/main">
             <a:pPr algn="l">
+              <a:buNone/>
               <a:defRPr sz="900" b="1">
                 <a:solidFill>
                   <a:srgbClr val="0F766E"/>
@@ -13623,6 +13801,7 @@
           <a:lstStyle xmlns:a="http://schemas.openxmlformats.org/drawingml/2006/main"/>
           <a:p xmlns:a="http://schemas.openxmlformats.org/drawingml/2006/main">
             <a:pPr algn="ctr">
+              <a:buNone/>
               <a:defRPr sz="1500" b="1">
                 <a:solidFill>
                   <a:srgbClr val="063E62"/>
@@ -13681,6 +13860,7 @@
           <a:lstStyle xmlns:a="http://schemas.openxmlformats.org/drawingml/2006/main"/>
           <a:p xmlns:a="http://schemas.openxmlformats.org/drawingml/2006/main">
             <a:pPr algn="ctr">
+              <a:buNone/>
               <a:defRPr sz="1800" b="1">
                 <a:solidFill>
                   <a:srgbClr val="0F766E"/>
@@ -13774,6 +13954,7 @@
           <a:lstStyle xmlns:a="http://schemas.openxmlformats.org/drawingml/2006/main"/>
           <a:p xmlns:a="http://schemas.openxmlformats.org/drawingml/2006/main">
             <a:pPr algn="l">
+              <a:buNone/>
               <a:defRPr sz="900" b="1">
                 <a:solidFill>
                   <a:srgbClr val="0F766E"/>
@@ -13832,6 +14013,7 @@
           <a:lstStyle xmlns:a="http://schemas.openxmlformats.org/drawingml/2006/main"/>
           <a:p xmlns:a="http://schemas.openxmlformats.org/drawingml/2006/main">
             <a:pPr algn="ctr">
+              <a:buNone/>
               <a:defRPr sz="1500" b="1">
                 <a:solidFill>
                   <a:srgbClr val="063E62"/>
@@ -13890,6 +14072,7 @@
           <a:lstStyle xmlns:a="http://schemas.openxmlformats.org/drawingml/2006/main"/>
           <a:p xmlns:a="http://schemas.openxmlformats.org/drawingml/2006/main">
             <a:pPr algn="ctr">
+              <a:buNone/>
               <a:defRPr sz="1650" b="1">
                 <a:solidFill>
                   <a:srgbClr val="17364A"/>
@@ -13948,6 +14131,7 @@
           <a:lstStyle xmlns:a="http://schemas.openxmlformats.org/drawingml/2006/main"/>
           <a:p xmlns:a="http://schemas.openxmlformats.org/drawingml/2006/main">
             <a:pPr algn="l">
+              <a:buNone/>
               <a:defRPr sz="750" b="1">
                 <a:solidFill>
                   <a:srgbClr val="5E7483"/>
@@ -14028,6 +14212,7 @@
           <a:lstStyle xmlns:a="http://schemas.openxmlformats.org/drawingml/2006/main"/>
           <a:p xmlns:a="http://schemas.openxmlformats.org/drawingml/2006/main">
             <a:pPr algn="l">
+              <a:buNone/>
               <a:defRPr sz="975" b="1">
                 <a:solidFill>
                   <a:srgbClr val="0F766E"/>
@@ -14086,6 +14271,7 @@
           <a:lstStyle xmlns:a="http://schemas.openxmlformats.org/drawingml/2006/main"/>
           <a:p xmlns:a="http://schemas.openxmlformats.org/drawingml/2006/main">
             <a:pPr algn="l">
+              <a:buNone/>
               <a:defRPr sz="2850" b="1">
                 <a:solidFill>
                   <a:srgbClr val="063E62"/>
@@ -14144,6 +14330,7 @@
           <a:lstStyle xmlns:a="http://schemas.openxmlformats.org/drawingml/2006/main"/>
           <a:p xmlns:a="http://schemas.openxmlformats.org/drawingml/2006/main">
             <a:pPr algn="r">
+              <a:buNone/>
               <a:defRPr sz="975" b="1">
                 <a:solidFill>
                   <a:srgbClr val="5E7483"/>
@@ -14169,14 +14356,14 @@
       </p:sp>
       <p:pic>
         <p:nvPicPr>
-          <p:cNvPr id="15" name=""/>
+          <p:cNvPr id="17" name=""/>
           <p:cNvPicPr>
             <a:picLocks xmlns:a="http://schemas.openxmlformats.org/drawingml/2006/main" noChangeAspect="1"/>
           </p:cNvPicPr>
           <p:nvPr/>
         </p:nvPicPr>
         <p:blipFill>
-          <a:blip xmlns:r="http://schemas.openxmlformats.org/officeDocument/2006/relationships" xmlns:a="http://schemas.openxmlformats.org/drawingml/2006/main" r:embed="R6491e759e8774364"/>
+          <a:blip xmlns:r="http://schemas.openxmlformats.org/officeDocument/2006/relationships" xmlns:a="http://schemas.openxmlformats.org/drawingml/2006/main" r:embed="R2727a322ab1c42cd"/>
           <a:srcRect xmlns:a="http://schemas.openxmlformats.org/drawingml/2006/main" l="0" t="28227" r="0" b="28227"/>
           <a:stretch xmlns:a="http://schemas.openxmlformats.org/drawingml/2006/main">
             <a:fillRect l="0" t="0" r="0" b="0"/>
@@ -14264,6 +14451,7 @@
           <a:lstStyle xmlns:a="http://schemas.openxmlformats.org/drawingml/2006/main"/>
           <a:p xmlns:a="http://schemas.openxmlformats.org/drawingml/2006/main">
             <a:pPr algn="l">
+              <a:buNone/>
               <a:defRPr sz="1650" b="1">
                 <a:solidFill>
                   <a:srgbClr val="B42318"/>
@@ -14322,6 +14510,7 @@
           <a:lstStyle xmlns:a="http://schemas.openxmlformats.org/drawingml/2006/main"/>
           <a:p xmlns:a="http://schemas.openxmlformats.org/drawingml/2006/main">
             <a:pPr algn="l">
+              <a:buNone/>
               <a:defRPr sz="1350" b="0">
                 <a:solidFill>
                   <a:srgbClr val="17364A"/>
@@ -14345,6 +14534,7 @@
           </a:p>
           <a:p xmlns:a="http://schemas.openxmlformats.org/drawingml/2006/main">
             <a:pPr algn="l">
+              <a:buNone/>
               <a:defRPr sz="1350" b="0">
                 <a:solidFill>
                   <a:srgbClr val="17364A"/>
@@ -14368,6 +14558,7 @@
           </a:p>
           <a:p xmlns:a="http://schemas.openxmlformats.org/drawingml/2006/main">
             <a:pPr algn="l">
+              <a:buNone/>
               <a:defRPr sz="1350" b="0">
                 <a:solidFill>
                   <a:srgbClr val="17364A"/>
@@ -14391,6 +14582,7 @@
           </a:p>
           <a:p xmlns:a="http://schemas.openxmlformats.org/drawingml/2006/main">
             <a:pPr algn="l">
+              <a:buNone/>
               <a:defRPr sz="1350" b="0">
                 <a:solidFill>
                   <a:srgbClr val="17364A"/>
@@ -14484,6 +14676,7 @@
           <a:lstStyle xmlns:a="http://schemas.openxmlformats.org/drawingml/2006/main"/>
           <a:p xmlns:a="http://schemas.openxmlformats.org/drawingml/2006/main">
             <a:pPr algn="l">
+              <a:buNone/>
               <a:defRPr sz="1650" b="1">
                 <a:solidFill>
                   <a:srgbClr val="FFFFFF"/>
@@ -14542,6 +14735,7 @@
           <a:lstStyle xmlns:a="http://schemas.openxmlformats.org/drawingml/2006/main"/>
           <a:p xmlns:a="http://schemas.openxmlformats.org/drawingml/2006/main">
             <a:pPr algn="l">
+              <a:buNone/>
               <a:defRPr sz="1350" b="0">
                 <a:solidFill>
                   <a:srgbClr val="D8EEF4"/>
@@ -14600,6 +14794,7 @@
           <a:lstStyle xmlns:a="http://schemas.openxmlformats.org/drawingml/2006/main"/>
           <a:p xmlns:a="http://schemas.openxmlformats.org/drawingml/2006/main">
             <a:pPr algn="l">
+              <a:buNone/>
               <a:defRPr sz="750" b="1">
                 <a:solidFill>
                   <a:srgbClr val="5E7483"/>
@@ -14680,6 +14875,7 @@
           <a:lstStyle xmlns:a="http://schemas.openxmlformats.org/drawingml/2006/main"/>
           <a:p xmlns:a="http://schemas.openxmlformats.org/drawingml/2006/main">
             <a:pPr algn="l">
+              <a:buNone/>
               <a:defRPr sz="975" b="1">
                 <a:solidFill>
                   <a:srgbClr val="0F766E"/>
@@ -14738,6 +14934,7 @@
           <a:lstStyle xmlns:a="http://schemas.openxmlformats.org/drawingml/2006/main"/>
           <a:p xmlns:a="http://schemas.openxmlformats.org/drawingml/2006/main">
             <a:pPr algn="l">
+              <a:buNone/>
               <a:defRPr sz="2850" b="1">
                 <a:solidFill>
                   <a:srgbClr val="063E62"/>
@@ -14796,6 +14993,7 @@
           <a:lstStyle xmlns:a="http://schemas.openxmlformats.org/drawingml/2006/main"/>
           <a:p xmlns:a="http://schemas.openxmlformats.org/drawingml/2006/main">
             <a:pPr algn="r">
+              <a:buNone/>
               <a:defRPr sz="975" b="1">
                 <a:solidFill>
                   <a:srgbClr val="5E7483"/>
@@ -14854,6 +15052,7 @@
           <a:lstStyle xmlns:a="http://schemas.openxmlformats.org/drawingml/2006/main"/>
           <a:p xmlns:a="http://schemas.openxmlformats.org/drawingml/2006/main">
             <a:pPr algn="l">
+              <a:buNone/>
               <a:defRPr sz="1500" b="0">
                 <a:solidFill>
                   <a:srgbClr val="5E7483"/>
@@ -14947,6 +15146,7 @@
           <a:lstStyle xmlns:a="http://schemas.openxmlformats.org/drawingml/2006/main"/>
           <a:p xmlns:a="http://schemas.openxmlformats.org/drawingml/2006/main">
             <a:pPr algn="l">
+              <a:buNone/>
               <a:defRPr sz="2850" b="1">
                 <a:solidFill>
                   <a:srgbClr val="0F766E"/>
@@ -15005,6 +15205,7 @@
           <a:lstStyle xmlns:a="http://schemas.openxmlformats.org/drawingml/2006/main"/>
           <a:p xmlns:a="http://schemas.openxmlformats.org/drawingml/2006/main">
             <a:pPr algn="l">
+              <a:buNone/>
               <a:defRPr sz="1800" b="1">
                 <a:solidFill>
                   <a:srgbClr val="063E62"/>
@@ -15063,6 +15264,7 @@
           <a:lstStyle xmlns:a="http://schemas.openxmlformats.org/drawingml/2006/main"/>
           <a:p xmlns:a="http://schemas.openxmlformats.org/drawingml/2006/main">
             <a:pPr algn="l">
+              <a:buNone/>
               <a:defRPr sz="1275" b="0">
                 <a:solidFill>
                   <a:srgbClr val="5E7483"/>
@@ -15156,6 +15358,7 @@
           <a:lstStyle xmlns:a="http://schemas.openxmlformats.org/drawingml/2006/main"/>
           <a:p xmlns:a="http://schemas.openxmlformats.org/drawingml/2006/main">
             <a:pPr algn="l">
+              <a:buNone/>
               <a:defRPr sz="2850" b="1">
                 <a:solidFill>
                   <a:srgbClr val="0F766E"/>
@@ -15214,6 +15417,7 @@
           <a:lstStyle xmlns:a="http://schemas.openxmlformats.org/drawingml/2006/main"/>
           <a:p xmlns:a="http://schemas.openxmlformats.org/drawingml/2006/main">
             <a:pPr algn="l">
+              <a:buNone/>
               <a:defRPr sz="1800" b="1">
                 <a:solidFill>
                   <a:srgbClr val="063E62"/>
@@ -15272,6 +15476,7 @@
           <a:lstStyle xmlns:a="http://schemas.openxmlformats.org/drawingml/2006/main"/>
           <a:p xmlns:a="http://schemas.openxmlformats.org/drawingml/2006/main">
             <a:pPr algn="l">
+              <a:buNone/>
               <a:defRPr sz="1275" b="0">
                 <a:solidFill>
                   <a:srgbClr val="5E7483"/>
@@ -15365,6 +15570,7 @@
           <a:lstStyle xmlns:a="http://schemas.openxmlformats.org/drawingml/2006/main"/>
           <a:p xmlns:a="http://schemas.openxmlformats.org/drawingml/2006/main">
             <a:pPr algn="l">
+              <a:buNone/>
               <a:defRPr sz="2850" b="1">
                 <a:solidFill>
                   <a:srgbClr val="0F766E"/>
@@ -15423,6 +15629,7 @@
           <a:lstStyle xmlns:a="http://schemas.openxmlformats.org/drawingml/2006/main"/>
           <a:p xmlns:a="http://schemas.openxmlformats.org/drawingml/2006/main">
             <a:pPr algn="l">
+              <a:buNone/>
               <a:defRPr sz="1800" b="1">
                 <a:solidFill>
                   <a:srgbClr val="063E62"/>
@@ -15481,6 +15688,7 @@
           <a:lstStyle xmlns:a="http://schemas.openxmlformats.org/drawingml/2006/main"/>
           <a:p xmlns:a="http://schemas.openxmlformats.org/drawingml/2006/main">
             <a:pPr algn="l">
+              <a:buNone/>
               <a:defRPr sz="1275" b="0">
                 <a:solidFill>
                   <a:srgbClr val="5E7483"/>
@@ -15539,6 +15747,7 @@
           <a:lstStyle xmlns:a="http://schemas.openxmlformats.org/drawingml/2006/main"/>
           <a:p xmlns:a="http://schemas.openxmlformats.org/drawingml/2006/main">
             <a:pPr algn="l">
+              <a:buNone/>
               <a:defRPr sz="750" b="1">
                 <a:solidFill>
                   <a:srgbClr val="5E7483"/>
@@ -15619,6 +15828,7 @@
           <a:lstStyle xmlns:a="http://schemas.openxmlformats.org/drawingml/2006/main"/>
           <a:p xmlns:a="http://schemas.openxmlformats.org/drawingml/2006/main">
             <a:pPr algn="l">
+              <a:buNone/>
               <a:defRPr sz="975" b="1">
                 <a:solidFill>
                   <a:srgbClr val="0F766E"/>
@@ -15677,6 +15887,7 @@
           <a:lstStyle xmlns:a="http://schemas.openxmlformats.org/drawingml/2006/main"/>
           <a:p xmlns:a="http://schemas.openxmlformats.org/drawingml/2006/main">
             <a:pPr algn="l">
+              <a:buNone/>
               <a:defRPr sz="2850" b="1">
                 <a:solidFill>
                   <a:srgbClr val="063E62"/>
@@ -15735,6 +15946,7 @@
           <a:lstStyle xmlns:a="http://schemas.openxmlformats.org/drawingml/2006/main"/>
           <a:p xmlns:a="http://schemas.openxmlformats.org/drawingml/2006/main">
             <a:pPr algn="r">
+              <a:buNone/>
               <a:defRPr sz="975" b="1">
                 <a:solidFill>
                   <a:srgbClr val="5E7483"/>
@@ -15760,14 +15972,14 @@
       </p:sp>
       <p:pic>
         <p:nvPicPr>
-          <p:cNvPr id="15" name=""/>
+          <p:cNvPr id="17" name=""/>
           <p:cNvPicPr>
             <a:picLocks xmlns:a="http://schemas.openxmlformats.org/drawingml/2006/main" noChangeAspect="1"/>
           </p:cNvPicPr>
           <p:nvPr/>
         </p:nvPicPr>
         <p:blipFill>
-          <a:blip xmlns:r="http://schemas.openxmlformats.org/officeDocument/2006/relationships" xmlns:a="http://schemas.openxmlformats.org/drawingml/2006/main" r:embed="R516d50243d434ea7"/>
+          <a:blip xmlns:r="http://schemas.openxmlformats.org/officeDocument/2006/relationships" xmlns:a="http://schemas.openxmlformats.org/drawingml/2006/main" r:embed="R7f2af6f84b9e4d10"/>
           <a:stretch xmlns:a="http://schemas.openxmlformats.org/drawingml/2006/main"/>
         </p:blipFill>
         <p:spPr>
@@ -15817,6 +16029,7 @@
           <a:lstStyle xmlns:a="http://schemas.openxmlformats.org/drawingml/2006/main"/>
           <a:p xmlns:a="http://schemas.openxmlformats.org/drawingml/2006/main">
             <a:pPr algn="l">
+              <a:buNone/>
               <a:defRPr sz="1500" b="1">
                 <a:solidFill>
                   <a:srgbClr val="063E62"/>
@@ -15875,6 +16088,7 @@
           <a:lstStyle xmlns:a="http://schemas.openxmlformats.org/drawingml/2006/main"/>
           <a:p xmlns:a="http://schemas.openxmlformats.org/drawingml/2006/main">
             <a:pPr algn="l">
+              <a:buNone/>
               <a:defRPr sz="1200" b="0">
                 <a:solidFill>
                   <a:srgbClr val="5E7483"/>
@@ -15933,6 +16147,7 @@
           <a:lstStyle xmlns:a="http://schemas.openxmlformats.org/drawingml/2006/main"/>
           <a:p xmlns:a="http://schemas.openxmlformats.org/drawingml/2006/main">
             <a:pPr algn="l">
+              <a:buNone/>
               <a:defRPr sz="1500" b="1">
                 <a:solidFill>
                   <a:srgbClr val="063E62"/>
@@ -15991,6 +16206,7 @@
           <a:lstStyle xmlns:a="http://schemas.openxmlformats.org/drawingml/2006/main"/>
           <a:p xmlns:a="http://schemas.openxmlformats.org/drawingml/2006/main">
             <a:pPr algn="l">
+              <a:buNone/>
               <a:defRPr sz="1200" b="0">
                 <a:solidFill>
                   <a:srgbClr val="5E7483"/>
@@ -16049,6 +16265,7 @@
           <a:lstStyle xmlns:a="http://schemas.openxmlformats.org/drawingml/2006/main"/>
           <a:p xmlns:a="http://schemas.openxmlformats.org/drawingml/2006/main">
             <a:pPr algn="l">
+              <a:buNone/>
               <a:defRPr sz="1500" b="1">
                 <a:solidFill>
                   <a:srgbClr val="063E62"/>
@@ -16107,6 +16324,7 @@
           <a:lstStyle xmlns:a="http://schemas.openxmlformats.org/drawingml/2006/main"/>
           <a:p xmlns:a="http://schemas.openxmlformats.org/drawingml/2006/main">
             <a:pPr algn="l">
+              <a:buNone/>
               <a:defRPr sz="1200" b="0">
                 <a:solidFill>
                   <a:srgbClr val="5E7483"/>
@@ -16165,6 +16383,7 @@
           <a:lstStyle xmlns:a="http://schemas.openxmlformats.org/drawingml/2006/main"/>
           <a:p xmlns:a="http://schemas.openxmlformats.org/drawingml/2006/main">
             <a:pPr algn="l">
+              <a:buNone/>
               <a:defRPr sz="750" b="1">
                 <a:solidFill>
                   <a:srgbClr val="5E7483"/>

</xml_diff>

<commit_message>
Add project credits to presentation
</commit_message>
<xml_diff>
--- a/app/static/My-ThreatLens-Presentation.pptx
+++ b/app/static/My-ThreatLens-Presentation.pptx
@@ -2,27 +2,27 @@
 <file path=ppt/presentation.xml><?xml version="1.0" encoding="utf-8"?>
 <p:presentation xmlns:p="http://schemas.openxmlformats.org/presentationml/2006/main">
   <p:sldMasterIdLst>
-    <p:sldMasterId xmlns:r="http://schemas.openxmlformats.org/officeDocument/2006/relationships" id="2147483648" r:id="R62e15ba9d86c441b"/>
+    <p:sldMasterId xmlns:r="http://schemas.openxmlformats.org/officeDocument/2006/relationships" id="2147483648" r:id="R86e9cc89facd4e32"/>
   </p:sldMasterIdLst>
   <p:notesMasterIdLst>
-    <p:notesMasterId xmlns:r="http://schemas.openxmlformats.org/officeDocument/2006/relationships" r:id="R02d3458f75ca4006"/>
+    <p:notesMasterId xmlns:r="http://schemas.openxmlformats.org/officeDocument/2006/relationships" r:id="R6ef9a53b6d2248c3"/>
   </p:notesMasterIdLst>
   <p:sldIdLst>
-    <p:sldId xmlns:r="http://schemas.openxmlformats.org/officeDocument/2006/relationships" id="256" r:id="R1a9648cd4e4a4860"/>
-    <p:sldId xmlns:r="http://schemas.openxmlformats.org/officeDocument/2006/relationships" id="257" r:id="R7fb2961f68a24d4b"/>
-    <p:sldId xmlns:r="http://schemas.openxmlformats.org/officeDocument/2006/relationships" id="258" r:id="R404f5e57ae214671"/>
-    <p:sldId xmlns:r="http://schemas.openxmlformats.org/officeDocument/2006/relationships" id="259" r:id="R97a2bacfebac48cb"/>
-    <p:sldId xmlns:r="http://schemas.openxmlformats.org/officeDocument/2006/relationships" id="260" r:id="R0c2d1eb628f94a28"/>
-    <p:sldId xmlns:r="http://schemas.openxmlformats.org/officeDocument/2006/relationships" id="261" r:id="Ra755f51752704c96"/>
-    <p:sldId xmlns:r="http://schemas.openxmlformats.org/officeDocument/2006/relationships" id="262" r:id="R46cf4a636f6c439c"/>
-    <p:sldId xmlns:r="http://schemas.openxmlformats.org/officeDocument/2006/relationships" id="263" r:id="R00687f2b1880427b"/>
-    <p:sldId xmlns:r="http://schemas.openxmlformats.org/officeDocument/2006/relationships" id="264" r:id="R1dc7f977b58b4cc4"/>
-    <p:sldId xmlns:r="http://schemas.openxmlformats.org/officeDocument/2006/relationships" id="265" r:id="Rc85bbfc10b744fcf"/>
-    <p:sldId xmlns:r="http://schemas.openxmlformats.org/officeDocument/2006/relationships" id="266" r:id="R15e4c9b4a6554153"/>
-    <p:sldId xmlns:r="http://schemas.openxmlformats.org/officeDocument/2006/relationships" id="267" r:id="R3b4b41a0da694248"/>
-    <p:sldId xmlns:r="http://schemas.openxmlformats.org/officeDocument/2006/relationships" id="268" r:id="R147baf797d17420d"/>
-    <p:sldId xmlns:r="http://schemas.openxmlformats.org/officeDocument/2006/relationships" id="269" r:id="R30f42c9494964e29"/>
-    <p:sldId xmlns:r="http://schemas.openxmlformats.org/officeDocument/2006/relationships" id="270" r:id="R89e0c5a8310f420d"/>
+    <p:sldId xmlns:r="http://schemas.openxmlformats.org/officeDocument/2006/relationships" id="256" r:id="R14b3ee701b9444ea"/>
+    <p:sldId xmlns:r="http://schemas.openxmlformats.org/officeDocument/2006/relationships" id="257" r:id="R48a3cdbd810c40ab"/>
+    <p:sldId xmlns:r="http://schemas.openxmlformats.org/officeDocument/2006/relationships" id="258" r:id="Ra0f65088ffee4add"/>
+    <p:sldId xmlns:r="http://schemas.openxmlformats.org/officeDocument/2006/relationships" id="259" r:id="R13108659076c4b9a"/>
+    <p:sldId xmlns:r="http://schemas.openxmlformats.org/officeDocument/2006/relationships" id="260" r:id="R46dcd01d0ef64676"/>
+    <p:sldId xmlns:r="http://schemas.openxmlformats.org/officeDocument/2006/relationships" id="261" r:id="Rb12fa338a1734770"/>
+    <p:sldId xmlns:r="http://schemas.openxmlformats.org/officeDocument/2006/relationships" id="262" r:id="Ra8938de5211f4f08"/>
+    <p:sldId xmlns:r="http://schemas.openxmlformats.org/officeDocument/2006/relationships" id="263" r:id="R0ed722c5208e41c9"/>
+    <p:sldId xmlns:r="http://schemas.openxmlformats.org/officeDocument/2006/relationships" id="264" r:id="R537d5b0c954046ae"/>
+    <p:sldId xmlns:r="http://schemas.openxmlformats.org/officeDocument/2006/relationships" id="265" r:id="R72b0f4f4626c4a1d"/>
+    <p:sldId xmlns:r="http://schemas.openxmlformats.org/officeDocument/2006/relationships" id="266" r:id="R08ab99f297ce416f"/>
+    <p:sldId xmlns:r="http://schemas.openxmlformats.org/officeDocument/2006/relationships" id="267" r:id="R9b2a5fbdb1a146e3"/>
+    <p:sldId xmlns:r="http://schemas.openxmlformats.org/officeDocument/2006/relationships" id="268" r:id="Re91a76c61f0f4ed8"/>
+    <p:sldId xmlns:r="http://schemas.openxmlformats.org/officeDocument/2006/relationships" id="269" r:id="Rfae1b770894c425f"/>
+    <p:sldId xmlns:r="http://schemas.openxmlformats.org/officeDocument/2006/relationships" id="270" r:id="R9f6c073e0e9e4323"/>
   </p:sldIdLst>
   <p:sldSz cx="12192000" cy="6858000"/>
   <p:notesSz cx="6858000" cy="9144000"/>
@@ -1804,7 +1804,7 @@
   </p:cSld>
   <p:clrMap bg1="lt1" tx1="dk1" bg2="lt2" tx2="dk2" accent1="accent1" accent2="accent2" accent3="accent3" accent4="accent4" accent5="accent5" accent6="accent6" hlink="hlink" folHlink="folHlink"/>
   <p:sldLayoutIdLst>
-    <p:sldLayoutId xmlns:r="http://schemas.openxmlformats.org/officeDocument/2006/relationships" id="2147483649" r:id="R9d1a98b6645f4d97"/>
+    <p:sldLayoutId xmlns:r="http://schemas.openxmlformats.org/officeDocument/2006/relationships" id="2147483649" r:id="R6849995018dc4b13"/>
   </p:sldLayoutIdLst>
   <p:txStyles>
     <p:titleStyle>
@@ -2619,7 +2619,7 @@
           <p:nvPr/>
         </p:nvPicPr>
         <p:blipFill>
-          <a:blip xmlns:r="http://schemas.openxmlformats.org/officeDocument/2006/relationships" xmlns:a="http://schemas.openxmlformats.org/drawingml/2006/main" r:embed="Redd424a616cf431a"/>
+          <a:blip xmlns:r="http://schemas.openxmlformats.org/officeDocument/2006/relationships" xmlns:a="http://schemas.openxmlformats.org/drawingml/2006/main" r:embed="Re0168df3cac9404c"/>
           <a:srcRect xmlns:a="http://schemas.openxmlformats.org/drawingml/2006/main" l="22561" t="0" r="22561" b="0"/>
           <a:stretch xmlns:a="http://schemas.openxmlformats.org/drawingml/2006/main">
             <a:fillRect l="0" t="0" r="0" b="0"/>
@@ -7998,7 +7998,7 @@
           <p:nvPr/>
         </p:nvPicPr>
         <p:blipFill>
-          <a:blip xmlns:r="http://schemas.openxmlformats.org/officeDocument/2006/relationships" xmlns:a="http://schemas.openxmlformats.org/drawingml/2006/main" r:embed="R162d0001bbca44f2"/>
+          <a:blip xmlns:r="http://schemas.openxmlformats.org/officeDocument/2006/relationships" xmlns:a="http://schemas.openxmlformats.org/drawingml/2006/main" r:embed="R0f2206b602894a10"/>
           <a:srcRect xmlns:a="http://schemas.openxmlformats.org/drawingml/2006/main" l="0" t="40265" r="0" b="40265"/>
           <a:stretch xmlns:a="http://schemas.openxmlformats.org/drawingml/2006/main">
             <a:fillRect l="0" t="0" r="0" b="0"/>
@@ -8467,7 +8467,7 @@
           <p:nvPr/>
         </p:nvPicPr>
         <p:blipFill>
-          <a:blip xmlns:r="http://schemas.openxmlformats.org/officeDocument/2006/relationships" xmlns:a="http://schemas.openxmlformats.org/drawingml/2006/main" r:embed="Rf84dfce15f17453f"/>
+          <a:blip xmlns:r="http://schemas.openxmlformats.org/officeDocument/2006/relationships" xmlns:a="http://schemas.openxmlformats.org/drawingml/2006/main" r:embed="R4555bc274408478e"/>
           <a:stretch xmlns:a="http://schemas.openxmlformats.org/drawingml/2006/main"/>
         </p:blipFill>
         <p:spPr>
@@ -8882,23 +8882,143 @@
         </p:nvSpPr>
         <p:spPr>
           <a:xfrm xmlns:a="http://schemas.openxmlformats.org/drawingml/2006/main">
-            <a:off x="619125" y="6191250"/>
-            <a:ext cx="5238750" cy="228600"/>
-          </a:xfrm>
-          <a:prstGeom xmlns:a="http://schemas.openxmlformats.org/drawingml/2006/main" prst="rect">
-            <a:avLst/>
-          </a:prstGeom>
-          <a:noFill xmlns:a="http://schemas.openxmlformats.org/drawingml/2006/main"/>
-          <a:ln xmlns:a="http://schemas.openxmlformats.org/drawingml/2006/main" w="0">
-            <a:noFill/>
-            <a:prstDash val="solid"/>
-          </a:ln>
-        </p:spPr>
-        <p:txBody>
-          <a:bodyPr xmlns:a="http://schemas.openxmlformats.org/drawingml/2006/main" anchor="ctr">
-            <a:normAutofit fontScale="92308"/>
-          </a:bodyPr>
-          <a:lstStyle xmlns:a="http://schemas.openxmlformats.org/drawingml/2006/main"/>
+            <a:off x="704850" y="4762500"/>
+            <a:ext cx="4476750" cy="1524000"/>
+          </a:xfrm>
+          <a:prstGeom xmlns:a="http://schemas.openxmlformats.org/drawingml/2006/main" prst="rect">
+            <a:avLst/>
+          </a:prstGeom>
+          <a:noFill xmlns:a="http://schemas.openxmlformats.org/drawingml/2006/main"/>
+          <a:ln xmlns:a="http://schemas.openxmlformats.org/drawingml/2006/main" w="0">
+            <a:noFill/>
+            <a:prstDash val="solid"/>
+          </a:ln>
+        </p:spPr>
+        <p:txBody>
+          <a:bodyPr xmlns:a="http://schemas.openxmlformats.org/drawingml/2006/main" anchor="ctr">
+            <a:normAutofit fontScale="100000"/>
+          </a:bodyPr>
+          <a:lstStyle xmlns:a="http://schemas.openxmlformats.org/drawingml/2006/main"/>
+          <a:p xmlns:a="http://schemas.openxmlformats.org/drawingml/2006/main">
+            <a:pPr algn="l">
+              <a:buNone/>
+              <a:defRPr sz="1200" b="1">
+                <a:solidFill>
+                  <a:srgbClr val="BBD9E5"/>
+                </a:solidFill>
+                <a:latin typeface="Aptos"/>
+                <a:ea typeface="Aptos"/>
+                <a:cs typeface="Aptos"/>
+              </a:defRPr>
+            </a:pPr>
+            <a:r>
+              <a:rPr sz="1200" b="1">
+                <a:solidFill>
+                  <a:srgbClr val="BBD9E5"/>
+                </a:solidFill>
+                <a:latin typeface="Aptos"/>
+                <a:ea typeface="Aptos"/>
+                <a:cs typeface="Aptos"/>
+              </a:rPr>
+              <a:t>PROJECT TEAM</a:t>
+            </a:r>
+          </a:p>
+          <a:p xmlns:a="http://schemas.openxmlformats.org/drawingml/2006/main">
+            <a:pPr algn="l">
+              <a:buNone/>
+              <a:defRPr sz="1200" b="1">
+                <a:solidFill>
+                  <a:srgbClr val="BBD9E5"/>
+                </a:solidFill>
+                <a:latin typeface="Aptos"/>
+                <a:ea typeface="Aptos"/>
+                <a:cs typeface="Aptos"/>
+              </a:defRPr>
+            </a:pPr>
+            <a:r>
+              <a:rPr sz="1200" b="1">
+                <a:solidFill>
+                  <a:srgbClr val="BBD9E5"/>
+                </a:solidFill>
+                <a:latin typeface="Aptos"/>
+                <a:ea typeface="Aptos"/>
+                <a:cs typeface="Aptos"/>
+              </a:rPr>
+              <a:t>Arsen Eliane</a:t>
+            </a:r>
+          </a:p>
+          <a:p xmlns:a="http://schemas.openxmlformats.org/drawingml/2006/main">
+            <a:pPr algn="l">
+              <a:buNone/>
+              <a:defRPr sz="1200" b="1">
+                <a:solidFill>
+                  <a:srgbClr val="BBD9E5"/>
+                </a:solidFill>
+                <a:latin typeface="Aptos"/>
+                <a:ea typeface="Aptos"/>
+                <a:cs typeface="Aptos"/>
+              </a:defRPr>
+            </a:pPr>
+            <a:r>
+              <a:rPr sz="1200" b="1">
+                <a:solidFill>
+                  <a:srgbClr val="BBD9E5"/>
+                </a:solidFill>
+                <a:latin typeface="Aptos"/>
+                <a:ea typeface="Aptos"/>
+                <a:cs typeface="Aptos"/>
+              </a:rPr>
+              <a:t>Abdallah Asfour</a:t>
+            </a:r>
+          </a:p>
+          <a:p xmlns:a="http://schemas.openxmlformats.org/drawingml/2006/main">
+            <a:pPr algn="l">
+              <a:buNone/>
+              <a:defRPr sz="1200" b="1">
+                <a:solidFill>
+                  <a:srgbClr val="BBD9E5"/>
+                </a:solidFill>
+                <a:latin typeface="Aptos"/>
+                <a:ea typeface="Aptos"/>
+                <a:cs typeface="Aptos"/>
+              </a:defRPr>
+            </a:pPr>
+            <a:r>
+              <a:rPr sz="1200" b="1">
+                <a:solidFill>
+                  <a:srgbClr val="BBD9E5"/>
+                </a:solidFill>
+                <a:latin typeface="Aptos"/>
+                <a:ea typeface="Aptos"/>
+                <a:cs typeface="Aptos"/>
+              </a:rPr>
+              <a:t>Alberto Nahra</a:t>
+            </a:r>
+          </a:p>
+          <a:p xmlns:a="http://schemas.openxmlformats.org/drawingml/2006/main">
+            <a:pPr algn="l">
+              <a:buNone/>
+              <a:defRPr sz="1200" b="1">
+                <a:solidFill>
+                  <a:srgbClr val="BBD9E5"/>
+                </a:solidFill>
+                <a:latin typeface="Aptos"/>
+                <a:ea typeface="Aptos"/>
+                <a:cs typeface="Aptos"/>
+              </a:defRPr>
+            </a:pPr>
+            <a:r>
+              <a:rPr sz="1200" b="1">
+                <a:solidFill>
+                  <a:srgbClr val="BBD9E5"/>
+                </a:solidFill>
+                <a:latin typeface="Aptos"/>
+                <a:ea typeface="Aptos"/>
+                <a:cs typeface="Aptos"/>
+              </a:rPr>
+              <a:t>Miguel Jallad</a:t>
+            </a:r>
+          </a:p>
           <a:p xmlns:a="http://schemas.openxmlformats.org/drawingml/2006/main">
             <a:pPr algn="l">
               <a:buNone/>
@@ -8920,7 +9040,31 @@
                 <a:ea typeface="Aptos"/>
                 <a:cs typeface="Aptos"/>
               </a:rPr>
-              <a:t>My ThreatLens · 2026</a:t>
+              <a:t/>
+            </a:r>
+          </a:p>
+          <a:p xmlns:a="http://schemas.openxmlformats.org/drawingml/2006/main">
+            <a:pPr algn="l">
+              <a:buNone/>
+              <a:defRPr sz="1200" b="1">
+                <a:solidFill>
+                  <a:srgbClr val="BBD9E5"/>
+                </a:solidFill>
+                <a:latin typeface="Aptos"/>
+                <a:ea typeface="Aptos"/>
+                <a:cs typeface="Aptos"/>
+              </a:defRPr>
+            </a:pPr>
+            <a:r>
+              <a:rPr sz="1200" b="1">
+                <a:solidFill>
+                  <a:srgbClr val="BBD9E5"/>
+                </a:solidFill>
+                <a:latin typeface="Aptos"/>
+                <a:ea typeface="Aptos"/>
+                <a:cs typeface="Aptos"/>
+              </a:rPr>
+              <a:t>With the guidance of Ali Nasrallah</a:t>
             </a:r>
           </a:p>
         </p:txBody>
@@ -10239,7 +10383,7 @@
           <p:nvPr/>
         </p:nvPicPr>
         <p:blipFill>
-          <a:blip xmlns:r="http://schemas.openxmlformats.org/officeDocument/2006/relationships" xmlns:a="http://schemas.openxmlformats.org/drawingml/2006/main" r:embed="R2118ac70d74b44e8"/>
+          <a:blip xmlns:r="http://schemas.openxmlformats.org/officeDocument/2006/relationships" xmlns:a="http://schemas.openxmlformats.org/drawingml/2006/main" r:embed="Rd5600509f0ae414f"/>
           <a:stretch xmlns:a="http://schemas.openxmlformats.org/drawingml/2006/main"/>
         </p:blipFill>
         <p:spPr>
@@ -10962,7 +11106,7 @@
       </p:sp>
       <p:cxnSp>
         <p:nvCxnSpPr>
-          <p:cNvPr id="29" name=""/>
+          <p:cNvPr id="33" name=""/>
           <p:cNvCxnSpPr/>
           <p:nvPr/>
         </p:nvCxnSpPr>
@@ -12089,7 +12233,7 @@
           <p:nvPr/>
         </p:nvPicPr>
         <p:blipFill>
-          <a:blip xmlns:r="http://schemas.openxmlformats.org/officeDocument/2006/relationships" xmlns:a="http://schemas.openxmlformats.org/drawingml/2006/main" r:embed="Rf5f913c772fc43eb"/>
+          <a:blip xmlns:r="http://schemas.openxmlformats.org/officeDocument/2006/relationships" xmlns:a="http://schemas.openxmlformats.org/drawingml/2006/main" r:embed="Ra766d86746fd4f03"/>
           <a:srcRect xmlns:a="http://schemas.openxmlformats.org/drawingml/2006/main" l="2697" t="0" r="2697" b="0"/>
           <a:stretch xmlns:a="http://schemas.openxmlformats.org/drawingml/2006/main">
             <a:fillRect l="0" t="0" r="0" b="0"/>
@@ -14363,7 +14507,7 @@
           <p:nvPr/>
         </p:nvPicPr>
         <p:blipFill>
-          <a:blip xmlns:r="http://schemas.openxmlformats.org/officeDocument/2006/relationships" xmlns:a="http://schemas.openxmlformats.org/drawingml/2006/main" r:embed="R2727a322ab1c42cd"/>
+          <a:blip xmlns:r="http://schemas.openxmlformats.org/officeDocument/2006/relationships" xmlns:a="http://schemas.openxmlformats.org/drawingml/2006/main" r:embed="R844c45bf48934b14"/>
           <a:srcRect xmlns:a="http://schemas.openxmlformats.org/drawingml/2006/main" l="0" t="28227" r="0" b="28227"/>
           <a:stretch xmlns:a="http://schemas.openxmlformats.org/drawingml/2006/main">
             <a:fillRect l="0" t="0" r="0" b="0"/>
@@ -15979,7 +16123,7 @@
           <p:nvPr/>
         </p:nvPicPr>
         <p:blipFill>
-          <a:blip xmlns:r="http://schemas.openxmlformats.org/officeDocument/2006/relationships" xmlns:a="http://schemas.openxmlformats.org/drawingml/2006/main" r:embed="R7f2af6f84b9e4d10"/>
+          <a:blip xmlns:r="http://schemas.openxmlformats.org/officeDocument/2006/relationships" xmlns:a="http://schemas.openxmlformats.org/drawingml/2006/main" r:embed="R45a3e589737f423c"/>
           <a:stretch xmlns:a="http://schemas.openxmlformats.org/drawingml/2006/main"/>
         </p:blipFill>
         <p:spPr>

</xml_diff>

<commit_message>
Create database-backed local edition
</commit_message>
<xml_diff>
--- a/app/static/My-ThreatLens-Presentation.pptx
+++ b/app/static/My-ThreatLens-Presentation.pptx
@@ -2,27 +2,27 @@
 <file path=ppt/presentation.xml><?xml version="1.0" encoding="utf-8"?>
 <p:presentation xmlns:p="http://schemas.openxmlformats.org/presentationml/2006/main">
   <p:sldMasterIdLst>
-    <p:sldMasterId xmlns:r="http://schemas.openxmlformats.org/officeDocument/2006/relationships" id="2147483648" r:id="R86e9cc89facd4e32"/>
+    <p:sldMasterId xmlns:r="http://schemas.openxmlformats.org/officeDocument/2006/relationships" id="2147483648" r:id="Re0d442d952c94c60"/>
   </p:sldMasterIdLst>
   <p:notesMasterIdLst>
-    <p:notesMasterId xmlns:r="http://schemas.openxmlformats.org/officeDocument/2006/relationships" r:id="R6ef9a53b6d2248c3"/>
+    <p:notesMasterId xmlns:r="http://schemas.openxmlformats.org/officeDocument/2006/relationships" r:id="R35cee9665a9146dd"/>
   </p:notesMasterIdLst>
   <p:sldIdLst>
-    <p:sldId xmlns:r="http://schemas.openxmlformats.org/officeDocument/2006/relationships" id="256" r:id="R14b3ee701b9444ea"/>
-    <p:sldId xmlns:r="http://schemas.openxmlformats.org/officeDocument/2006/relationships" id="257" r:id="R48a3cdbd810c40ab"/>
-    <p:sldId xmlns:r="http://schemas.openxmlformats.org/officeDocument/2006/relationships" id="258" r:id="Ra0f65088ffee4add"/>
-    <p:sldId xmlns:r="http://schemas.openxmlformats.org/officeDocument/2006/relationships" id="259" r:id="R13108659076c4b9a"/>
-    <p:sldId xmlns:r="http://schemas.openxmlformats.org/officeDocument/2006/relationships" id="260" r:id="R46dcd01d0ef64676"/>
-    <p:sldId xmlns:r="http://schemas.openxmlformats.org/officeDocument/2006/relationships" id="261" r:id="Rb12fa338a1734770"/>
-    <p:sldId xmlns:r="http://schemas.openxmlformats.org/officeDocument/2006/relationships" id="262" r:id="Ra8938de5211f4f08"/>
-    <p:sldId xmlns:r="http://schemas.openxmlformats.org/officeDocument/2006/relationships" id="263" r:id="R0ed722c5208e41c9"/>
-    <p:sldId xmlns:r="http://schemas.openxmlformats.org/officeDocument/2006/relationships" id="264" r:id="R537d5b0c954046ae"/>
-    <p:sldId xmlns:r="http://schemas.openxmlformats.org/officeDocument/2006/relationships" id="265" r:id="R72b0f4f4626c4a1d"/>
-    <p:sldId xmlns:r="http://schemas.openxmlformats.org/officeDocument/2006/relationships" id="266" r:id="R08ab99f297ce416f"/>
-    <p:sldId xmlns:r="http://schemas.openxmlformats.org/officeDocument/2006/relationships" id="267" r:id="R9b2a5fbdb1a146e3"/>
-    <p:sldId xmlns:r="http://schemas.openxmlformats.org/officeDocument/2006/relationships" id="268" r:id="Re91a76c61f0f4ed8"/>
-    <p:sldId xmlns:r="http://schemas.openxmlformats.org/officeDocument/2006/relationships" id="269" r:id="Rfae1b770894c425f"/>
-    <p:sldId xmlns:r="http://schemas.openxmlformats.org/officeDocument/2006/relationships" id="270" r:id="R9f6c073e0e9e4323"/>
+    <p:sldId xmlns:r="http://schemas.openxmlformats.org/officeDocument/2006/relationships" id="256" r:id="R803069fe2a4e40df"/>
+    <p:sldId xmlns:r="http://schemas.openxmlformats.org/officeDocument/2006/relationships" id="257" r:id="Rcd330dcf187e456e"/>
+    <p:sldId xmlns:r="http://schemas.openxmlformats.org/officeDocument/2006/relationships" id="258" r:id="R67fac8790f1c4654"/>
+    <p:sldId xmlns:r="http://schemas.openxmlformats.org/officeDocument/2006/relationships" id="259" r:id="Rdfab95224946496b"/>
+    <p:sldId xmlns:r="http://schemas.openxmlformats.org/officeDocument/2006/relationships" id="260" r:id="R58310388462d406b"/>
+    <p:sldId xmlns:r="http://schemas.openxmlformats.org/officeDocument/2006/relationships" id="261" r:id="R47854d48bf9a42d8"/>
+    <p:sldId xmlns:r="http://schemas.openxmlformats.org/officeDocument/2006/relationships" id="262" r:id="R71890d0ec724441d"/>
+    <p:sldId xmlns:r="http://schemas.openxmlformats.org/officeDocument/2006/relationships" id="263" r:id="R88551129ab1040f7"/>
+    <p:sldId xmlns:r="http://schemas.openxmlformats.org/officeDocument/2006/relationships" id="264" r:id="R517124d1154f4583"/>
+    <p:sldId xmlns:r="http://schemas.openxmlformats.org/officeDocument/2006/relationships" id="265" r:id="Rfbc509e8f32240a8"/>
+    <p:sldId xmlns:r="http://schemas.openxmlformats.org/officeDocument/2006/relationships" id="266" r:id="R7e12f151eaa94d69"/>
+    <p:sldId xmlns:r="http://schemas.openxmlformats.org/officeDocument/2006/relationships" id="267" r:id="R2d089196e3094ecb"/>
+    <p:sldId xmlns:r="http://schemas.openxmlformats.org/officeDocument/2006/relationships" id="268" r:id="R7517676f205042e8"/>
+    <p:sldId xmlns:r="http://schemas.openxmlformats.org/officeDocument/2006/relationships" id="269" r:id="R2b3ef5875c6b40ee"/>
+    <p:sldId xmlns:r="http://schemas.openxmlformats.org/officeDocument/2006/relationships" id="270" r:id="R83e9e99741ee4d75"/>
   </p:sldIdLst>
   <p:sldSz cx="12192000" cy="6858000"/>
   <p:notesSz cx="6858000" cy="9144000"/>
@@ -726,7 +726,7 @@
           <a:lstStyle xmlns:a="http://schemas.openxmlformats.org/drawingml/2006/main"/>
           <a:p xmlns:a="http://schemas.openxmlformats.org/drawingml/2006/main">
             <a:r>
-              <a:t>The browser owns the user experience and browser-specific setup backup. FastAPI handles authorization and APIs. Python services analyze content. SQLite stores workspace-scoped server records; secrets are injected as environment variables.</a:t>
+              <a:t>The browser provides the user experience. FastAPI handles account authorization and APIs. Python services analyze content. SQLite stores account-scoped setup records; provider secrets remain in the local environment file.</a:t>
             </a:r>
           </a:p>
           <a:p xmlns:a="http://schemas.openxmlformats.org/drawingml/2006/main">
@@ -741,7 +741,7 @@
           </a:p>
           <a:p xmlns:a="http://schemas.openxmlformats.org/drawingml/2006/main">
             <a:r>
-              <a:t>- My ThreatLens local application and repository (accessed 2026-08-16)</a:t>
+              <a:t>- My ThreatLens local application and repository (accessed 2026-08-17)</a:t>
             </a:r>
           </a:p>
           <a:p xmlns:a="http://schemas.openxmlformats.org/drawingml/2006/main">
@@ -816,7 +816,7 @@
           <a:lstStyle xmlns:a="http://schemas.openxmlformats.org/drawingml/2006/main"/>
           <a:p xmlns:a="http://schemas.openxmlformats.org/drawingml/2006/main">
             <a:r>
-              <a:t>This is a controlled demo access model, not enterprise identity management. Browser isolation prevents setup changes from propagating across machines, but users still share one login credential.</a:t>
+              <a:t>The local edition supports multiple user accounts with salted password hashes and account-scoped data. It is intended for a trusted local network unless an administrator adds production-grade network controls.</a:t>
             </a:r>
           </a:p>
           <a:p xmlns:a="http://schemas.openxmlformats.org/drawingml/2006/main">
@@ -831,7 +831,7 @@
           </a:p>
           <a:p xmlns:a="http://schemas.openxmlformats.org/drawingml/2006/main">
             <a:r>
-              <a:t>- My ThreatLens local application and repository (accessed 2026-08-16)</a:t>
+              <a:t>- My ThreatLens local application and repository (accessed 2026-08-17)</a:t>
             </a:r>
           </a:p>
           <a:p xmlns:a="http://schemas.openxmlformats.org/drawingml/2006/main">
@@ -1176,7 +1176,7 @@
           <a:lstStyle xmlns:a="http://schemas.openxmlformats.org/drawingml/2006/main"/>
           <a:p xmlns:a="http://schemas.openxmlformats.org/drawingml/2006/main">
             <a:r>
-              <a:t>The shared demonstration login controls access. A long-lived browser workspace cookie isolates configurations, while the authentication cookie is session-only.</a:t>
+              <a:t>Each local user creates a unique account. The authenticated user ID scopes setup and automation records in SQLite.</a:t>
             </a:r>
           </a:p>
           <a:p xmlns:a="http://schemas.openxmlformats.org/drawingml/2006/main">
@@ -1191,7 +1191,7 @@
           </a:p>
           <a:p xmlns:a="http://schemas.openxmlformats.org/drawingml/2006/main">
             <a:r>
-              <a:t>- My ThreatLens local application and repository (accessed 2026-08-16)</a:t>
+              <a:t>- My ThreatLens local application and repository (accessed 2026-08-17)</a:t>
             </a:r>
           </a:p>
           <a:p xmlns:a="http://schemas.openxmlformats.org/drawingml/2006/main">
@@ -1804,7 +1804,7 @@
   </p:cSld>
   <p:clrMap bg1="lt1" tx1="dk1" bg2="lt2" tx2="dk2" accent1="accent1" accent2="accent2" accent3="accent3" accent4="accent4" accent5="accent5" accent6="accent6" hlink="hlink" folHlink="folHlink"/>
   <p:sldLayoutIdLst>
-    <p:sldLayoutId xmlns:r="http://schemas.openxmlformats.org/officeDocument/2006/relationships" id="2147483649" r:id="R6849995018dc4b13"/>
+    <p:sldLayoutId xmlns:r="http://schemas.openxmlformats.org/officeDocument/2006/relationships" id="2147483649" r:id="R0536a69c3d364ec9"/>
   </p:sldLayoutIdLst>
   <p:txStyles>
     <p:titleStyle>
@@ -2619,7 +2619,7 @@
           <p:nvPr/>
         </p:nvPicPr>
         <p:blipFill>
-          <a:blip xmlns:r="http://schemas.openxmlformats.org/officeDocument/2006/relationships" xmlns:a="http://schemas.openxmlformats.org/drawingml/2006/main" r:embed="Re0168df3cac9404c"/>
+          <a:blip xmlns:r="http://schemas.openxmlformats.org/officeDocument/2006/relationships" xmlns:a="http://schemas.openxmlformats.org/drawingml/2006/main" r:embed="Ra022daac3e1340cb"/>
           <a:srcRect xmlns:a="http://schemas.openxmlformats.org/drawingml/2006/main" l="22561" t="0" r="22561" b="0"/>
           <a:stretch xmlns:a="http://schemas.openxmlformats.org/drawingml/2006/main">
             <a:fillRect l="0" t="0" r="0" b="0"/>
@@ -2691,7 +2691,7 @@
                 <a:ea typeface="Aptos"/>
                 <a:cs typeface="Aptos"/>
               </a:rPr>
-              <a:t>Internship project</a:t>
+              <a:t>Local security intelligence workspace</a:t>
             </a:r>
           </a:p>
         </p:txBody>
@@ -4192,7 +4192,7 @@
                 <a:ea typeface="Aptos"/>
                 <a:cs typeface="Aptos"/>
               </a:rPr>
-              <a:t>MY THREATLENS · INTERNSHIP PROJECT</a:t>
+              <a:t>MY THREATLENS · LOCAL EDITION</a:t>
             </a:r>
           </a:p>
         </p:txBody>
@@ -5077,7 +5077,7 @@
                 <a:ea typeface="Aptos"/>
                 <a:cs typeface="Aptos"/>
               </a:rPr>
-              <a:t>MY THREATLENS · INTERNSHIP PROJECT</a:t>
+              <a:t>MY THREATLENS · LOCAL EDITION</a:t>
             </a:r>
           </a:p>
         </p:txBody>
@@ -5488,7 +5488,7 @@
                 <a:ea typeface="Aptos"/>
                 <a:cs typeface="Aptos"/>
               </a:rPr>
-              <a:t>Session login · workspace cookie · browser setup backup</a:t>
+              <a:t>Session login · user account · database-backed setups</a:t>
             </a:r>
           </a:p>
         </p:txBody>
@@ -6124,7 +6124,7 @@
                 <a:ea typeface="Aptos"/>
                 <a:cs typeface="Aptos"/>
               </a:rPr>
-              <a:t>Workspace-scoped records · Zoho/SMTP · Ollama · Render</a:t>
+              <a:t>Account-scoped records · Zoho/SMTP · local or API Ollama</a:t>
             </a:r>
           </a:p>
         </p:txBody>
@@ -6183,7 +6183,7 @@
                 <a:ea typeface="Aptos"/>
                 <a:cs typeface="Aptos"/>
               </a:rPr>
-              <a:t>MY THREATLENS · INTERNSHIP PROJECT</a:t>
+              <a:t>MY THREATLENS · LOCAL EDITION</a:t>
             </a:r>
           </a:p>
         </p:txBody>
@@ -6594,7 +6594,7 @@
                 <a:ea typeface="Aptos"/>
                 <a:cs typeface="Aptos"/>
               </a:rPr>
-              <a:t>Shared demonstration identity</a:t>
+              <a:t>Unique local user accounts</a:t>
             </a:r>
           </a:p>
         </p:txBody>
@@ -7042,7 +7042,7 @@
                 <a:ea typeface="Aptos"/>
                 <a:cs typeface="Aptos"/>
               </a:rPr>
-              <a:t>Persistent random browser workspace ID</a:t>
+              <a:t>User ID owns the database workspace</a:t>
             </a:r>
           </a:p>
         </p:txBody>
@@ -7160,7 +7160,7 @@
                 <a:ea typeface="Aptos"/>
                 <a:cs typeface="Aptos"/>
               </a:rPr>
-              <a:t>Every API query is scoped to that workspace</a:t>
+              <a:t>Every API query is scoped to that user</a:t>
             </a:r>
           </a:p>
         </p:txBody>
@@ -7278,7 +7278,7 @@
                 <a:ea typeface="Aptos"/>
                 <a:cs typeface="Aptos"/>
               </a:rPr>
-              <a:t>Another computer receives a different workspace</a:t>
+              <a:t>Another account receives a separate workspace</a:t>
             </a:r>
           </a:p>
         </p:txBody>
@@ -7608,7 +7608,7 @@
                 <a:ea typeface="Aptos"/>
                 <a:cs typeface="Aptos"/>
               </a:rPr>
-              <a:t>No personal user email-account registration</a:t>
+              <a:t>No email address required for registration</a:t>
             </a:r>
           </a:p>
         </p:txBody>
@@ -7785,7 +7785,7 @@
                 <a:ea typeface="Aptos"/>
                 <a:cs typeface="Aptos"/>
               </a:rPr>
-              <a:t>MY THREATLENS · INTERNSHIP PROJECT</a:t>
+              <a:t>MY THREATLENS · LOCAL EDITION</a:t>
             </a:r>
           </a:p>
         </p:txBody>
@@ -7998,7 +7998,7 @@
           <p:nvPr/>
         </p:nvPicPr>
         <p:blipFill>
-          <a:blip xmlns:r="http://schemas.openxmlformats.org/officeDocument/2006/relationships" xmlns:a="http://schemas.openxmlformats.org/drawingml/2006/main" r:embed="R0f2206b602894a10"/>
+          <a:blip xmlns:r="http://schemas.openxmlformats.org/officeDocument/2006/relationships" xmlns:a="http://schemas.openxmlformats.org/drawingml/2006/main" r:embed="Re0262b18f9ab4faa"/>
           <a:srcRect xmlns:a="http://schemas.openxmlformats.org/drawingml/2006/main" l="0" t="40265" r="0" b="40265"/>
           <a:stretch xmlns:a="http://schemas.openxmlformats.org/drawingml/2006/main">
             <a:fillRect l="0" t="0" r="0" b="0"/>
@@ -8424,7 +8424,7 @@
                 <a:ea typeface="Aptos"/>
                 <a:cs typeface="Aptos"/>
               </a:rPr>
-              <a:t>MY THREATLENS · INTERNSHIP PROJECT</a:t>
+              <a:t>MY THREATLENS · LOCAL EDITION</a:t>
             </a:r>
           </a:p>
         </p:txBody>
@@ -8467,7 +8467,7 @@
           <p:nvPr/>
         </p:nvPicPr>
         <p:blipFill>
-          <a:blip xmlns:r="http://schemas.openxmlformats.org/officeDocument/2006/relationships" xmlns:a="http://schemas.openxmlformats.org/drawingml/2006/main" r:embed="R4555bc274408478e"/>
+          <a:blip xmlns:r="http://schemas.openxmlformats.org/officeDocument/2006/relationships" xmlns:a="http://schemas.openxmlformats.org/drawingml/2006/main" r:embed="R5f8e132e4fb949f0"/>
           <a:stretch xmlns:a="http://schemas.openxmlformats.org/drawingml/2006/main"/>
         </p:blipFill>
         <p:spPr>
@@ -8920,7 +8920,7 @@
                 <a:ea typeface="Aptos"/>
                 <a:cs typeface="Aptos"/>
               </a:rPr>
-              <a:t>PROJECT TEAM</a:t>
+              <a:t>LOCAL EDITION</a:t>
             </a:r>
           </a:p>
           <a:p xmlns:a="http://schemas.openxmlformats.org/drawingml/2006/main">
@@ -8944,7 +8944,7 @@
                 <a:ea typeface="Aptos"/>
                 <a:cs typeface="Aptos"/>
               </a:rPr>
-              <a:t>Arsen Eliane</a:t>
+              <a:t>Runs on port 8001</a:t>
             </a:r>
           </a:p>
           <a:p xmlns:a="http://schemas.openxmlformats.org/drawingml/2006/main">
@@ -8968,7 +8968,7 @@
                 <a:ea typeface="Aptos"/>
                 <a:cs typeface="Aptos"/>
               </a:rPr>
-              <a:t>Abdallah Asfour</a:t>
+              <a:t>Account-owned setups</a:t>
             </a:r>
           </a:p>
           <a:p xmlns:a="http://schemas.openxmlformats.org/drawingml/2006/main">
@@ -8992,7 +8992,7 @@
                 <a:ea typeface="Aptos"/>
                 <a:cs typeface="Aptos"/>
               </a:rPr>
-              <a:t>Alberto Nahra</a:t>
+              <a:t>Local or API Ollama</a:t>
             </a:r>
           </a:p>
           <a:p xmlns:a="http://schemas.openxmlformats.org/drawingml/2006/main">
@@ -9016,55 +9016,7 @@
                 <a:ea typeface="Aptos"/>
                 <a:cs typeface="Aptos"/>
               </a:rPr>
-              <a:t>Miguel Jallad</a:t>
-            </a:r>
-          </a:p>
-          <a:p xmlns:a="http://schemas.openxmlformats.org/drawingml/2006/main">
-            <a:pPr algn="l">
-              <a:buNone/>
-              <a:defRPr sz="975" b="1">
-                <a:solidFill>
-                  <a:srgbClr val="90C8D4"/>
-                </a:solidFill>
-                <a:latin typeface="Aptos"/>
-                <a:ea typeface="Aptos"/>
-                <a:cs typeface="Aptos"/>
-              </a:defRPr>
-            </a:pPr>
-            <a:r>
-              <a:rPr sz="975" b="1">
-                <a:solidFill>
-                  <a:srgbClr val="90C8D4"/>
-                </a:solidFill>
-                <a:latin typeface="Aptos"/>
-                <a:ea typeface="Aptos"/>
-                <a:cs typeface="Aptos"/>
-              </a:rPr>
-              <a:t/>
-            </a:r>
-          </a:p>
-          <a:p xmlns:a="http://schemas.openxmlformats.org/drawingml/2006/main">
-            <a:pPr algn="l">
-              <a:buNone/>
-              <a:defRPr sz="1200" b="1">
-                <a:solidFill>
-                  <a:srgbClr val="BBD9E5"/>
-                </a:solidFill>
-                <a:latin typeface="Aptos"/>
-                <a:ea typeface="Aptos"/>
-                <a:cs typeface="Aptos"/>
-              </a:defRPr>
-            </a:pPr>
-            <a:r>
-              <a:rPr sz="1200" b="1">
-                <a:solidFill>
-                  <a:srgbClr val="BBD9E5"/>
-                </a:solidFill>
-                <a:latin typeface="Aptos"/>
-                <a:ea typeface="Aptos"/>
-                <a:cs typeface="Aptos"/>
-              </a:rPr>
-              <a:t>With the guidance of Ali Nasrallah</a:t>
+              <a:t>Configurable email delivery</a:t>
             </a:r>
           </a:p>
         </p:txBody>
@@ -10170,7 +10122,7 @@
                 <a:ea typeface="Aptos"/>
                 <a:cs typeface="Aptos"/>
               </a:rPr>
-              <a:t>MY THREATLENS · INTERNSHIP PROJECT</a:t>
+              <a:t>MY THREATLENS · LOCAL EDITION</a:t>
             </a:r>
           </a:p>
         </p:txBody>
@@ -10310,7 +10262,7 @@
                 <a:ea typeface="Aptos"/>
                 <a:cs typeface="Aptos"/>
               </a:rPr>
-              <a:t>Simple login, independent computers</a:t>
+              <a:t>Local accounts, independent workspaces</a:t>
             </a:r>
           </a:p>
         </p:txBody>
@@ -10383,7 +10335,7 @@
           <p:nvPr/>
         </p:nvPicPr>
         <p:blipFill>
-          <a:blip xmlns:r="http://schemas.openxmlformats.org/officeDocument/2006/relationships" xmlns:a="http://schemas.openxmlformats.org/drawingml/2006/main" r:embed="Rd5600509f0ae414f"/>
+          <a:blip xmlns:r="http://schemas.openxmlformats.org/officeDocument/2006/relationships" xmlns:a="http://schemas.openxmlformats.org/drawingml/2006/main" r:embed="R7c562e286dd84343"/>
           <a:stretch xmlns:a="http://schemas.openxmlformats.org/drawingml/2006/main"/>
         </p:blipFill>
         <p:spPr>
@@ -10546,7 +10498,7 @@
                 <a:ea typeface="Aptos"/>
                 <a:cs typeface="Aptos"/>
               </a:rPr>
-              <a:t>Browser-session login</a:t>
+              <a:t>Local account login</a:t>
             </a:r>
           </a:p>
         </p:txBody>
@@ -10605,7 +10557,7 @@
                 <a:ea typeface="Aptos"/>
                 <a:cs typeface="Aptos"/>
               </a:rPr>
-              <a:t>The user signs in again after closing and reopening the browser.</a:t>
+              <a:t>Each user creates a unique username and strong password; no email address is required.</a:t>
             </a:r>
           </a:p>
         </p:txBody>
@@ -10664,7 +10616,7 @@
                 <a:ea typeface="Aptos"/>
                 <a:cs typeface="Aptos"/>
               </a:rPr>
-              <a:t>Separate workspace</a:t>
+              <a:t>Account-owned workspace</a:t>
             </a:r>
           </a:p>
         </p:txBody>
@@ -10723,7 +10675,7 @@
                 <a:ea typeface="Aptos"/>
                 <a:cs typeface="Aptos"/>
               </a:rPr>
-              <a:t>Each browser receives an independent identity and setup collection.</a:t>
+              <a:t>Every setup and automatic-email configuration is scoped to its owning account.</a:t>
             </a:r>
           </a:p>
         </p:txBody>
@@ -10782,7 +10734,7 @@
                 <a:ea typeface="Aptos"/>
                 <a:cs typeface="Aptos"/>
               </a:rPr>
-              <a:t>Persistent setups</a:t>
+              <a:t>Database persistence</a:t>
             </a:r>
           </a:p>
         </p:txBody>
@@ -10841,7 +10793,7 @@
                 <a:ea typeface="Aptos"/>
                 <a:cs typeface="Aptos"/>
               </a:rPr>
-              <a:t>Setup configuration remains saved for that browser; results and chat stay temporary.</a:t>
+              <a:t>Search parameters and setups remain available after logout, browser closure, or restart.</a:t>
             </a:r>
           </a:p>
         </p:txBody>
@@ -10900,7 +10852,7 @@
                 <a:ea typeface="Aptos"/>
                 <a:cs typeface="Aptos"/>
               </a:rPr>
-              <a:t>MY THREATLENS · INTERNSHIP PROJECT</a:t>
+              <a:t>MY THREATLENS · LOCAL EDITION</a:t>
             </a:r>
           </a:p>
         </p:txBody>
@@ -11106,7 +11058,7 @@
       </p:sp>
       <p:cxnSp>
         <p:nvCxnSpPr>
-          <p:cNvPr id="33" name=""/>
+          <p:cNvPr id="37" name=""/>
           <p:cNvCxnSpPr/>
           <p:nvPr/>
         </p:nvCxnSpPr>
@@ -12020,7 +11972,7 @@
                 <a:ea typeface="Aptos"/>
                 <a:cs typeface="Aptos"/>
               </a:rPr>
-              <a:t>MY THREATLENS · INTERNSHIP PROJECT</a:t>
+              <a:t>MY THREATLENS · LOCAL EDITION</a:t>
             </a:r>
           </a:p>
         </p:txBody>
@@ -12233,7 +12185,7 @@
           <p:nvPr/>
         </p:nvPicPr>
         <p:blipFill>
-          <a:blip xmlns:r="http://schemas.openxmlformats.org/officeDocument/2006/relationships" xmlns:a="http://schemas.openxmlformats.org/drawingml/2006/main" r:embed="Ra766d86746fd4f03"/>
+          <a:blip xmlns:r="http://schemas.openxmlformats.org/officeDocument/2006/relationships" xmlns:a="http://schemas.openxmlformats.org/drawingml/2006/main" r:embed="R0a02259677e74dac"/>
           <a:srcRect xmlns:a="http://schemas.openxmlformats.org/drawingml/2006/main" l="2697" t="0" r="2697" b="0"/>
           <a:stretch xmlns:a="http://schemas.openxmlformats.org/drawingml/2006/main">
             <a:fillRect l="0" t="0" r="0" b="0"/>
@@ -12764,7 +12716,7 @@
                 <a:ea typeface="Aptos"/>
                 <a:cs typeface="Aptos"/>
               </a:rPr>
-              <a:t>MY THREATLENS · INTERNSHIP PROJECT</a:t>
+              <a:t>MY THREATLENS · LOCAL EDITION</a:t>
             </a:r>
           </a:p>
         </p:txBody>
@@ -14294,7 +14246,7 @@
                 <a:ea typeface="Aptos"/>
                 <a:cs typeface="Aptos"/>
               </a:rPr>
-              <a:t>MY THREATLENS · INTERNSHIP PROJECT</a:t>
+              <a:t>MY THREATLENS · LOCAL EDITION</a:t>
             </a:r>
           </a:p>
         </p:txBody>
@@ -14507,7 +14459,7 @@
           <p:nvPr/>
         </p:nvPicPr>
         <p:blipFill>
-          <a:blip xmlns:r="http://schemas.openxmlformats.org/officeDocument/2006/relationships" xmlns:a="http://schemas.openxmlformats.org/drawingml/2006/main" r:embed="R844c45bf48934b14"/>
+          <a:blip xmlns:r="http://schemas.openxmlformats.org/officeDocument/2006/relationships" xmlns:a="http://schemas.openxmlformats.org/drawingml/2006/main" r:embed="R9761e081bc354ae5"/>
           <a:srcRect xmlns:a="http://schemas.openxmlformats.org/drawingml/2006/main" l="0" t="28227" r="0" b="28227"/>
           <a:stretch xmlns:a="http://schemas.openxmlformats.org/drawingml/2006/main">
             <a:fillRect l="0" t="0" r="0" b="0"/>
@@ -14957,7 +14909,7 @@
                 <a:ea typeface="Aptos"/>
                 <a:cs typeface="Aptos"/>
               </a:rPr>
-              <a:t>MY THREATLENS · INTERNSHIP PROJECT</a:t>
+              <a:t>MY THREATLENS · LOCAL EDITION</a:t>
             </a:r>
           </a:p>
         </p:txBody>
@@ -15910,7 +15862,7 @@
                 <a:ea typeface="Aptos"/>
                 <a:cs typeface="Aptos"/>
               </a:rPr>
-              <a:t>MY THREATLENS · INTERNSHIP PROJECT</a:t>
+              <a:t>MY THREATLENS · LOCAL EDITION</a:t>
             </a:r>
           </a:p>
         </p:txBody>
@@ -16123,7 +16075,7 @@
           <p:nvPr/>
         </p:nvPicPr>
         <p:blipFill>
-          <a:blip xmlns:r="http://schemas.openxmlformats.org/officeDocument/2006/relationships" xmlns:a="http://schemas.openxmlformats.org/drawingml/2006/main" r:embed="R45a3e589737f423c"/>
+          <a:blip xmlns:r="http://schemas.openxmlformats.org/officeDocument/2006/relationships" xmlns:a="http://schemas.openxmlformats.org/drawingml/2006/main" r:embed="R86cc97405f2a4506"/>
           <a:stretch xmlns:a="http://schemas.openxmlformats.org/drawingml/2006/main"/>
         </p:blipFill>
         <p:spPr>
@@ -16546,7 +16498,7 @@
                 <a:ea typeface="Aptos"/>
                 <a:cs typeface="Aptos"/>
               </a:rPr>
-              <a:t>MY THREATLENS · INTERNSHIP PROJECT</a:t>
+              <a:t>MY THREATLENS · LOCAL EDITION</a:t>
             </a:r>
           </a:p>
         </p:txBody>

</xml_diff>